<commit_message>
LO4 LO5 + EXTRA (python code)
</commit_message>
<xml_diff>
--- a/LabBook_10.pptx
+++ b/LabBook_10.pptx
@@ -5,10 +5,10 @@
     <p:sldMasterId id="2147483648" r:id="rId1"/>
   </p:sldMasterIdLst>
   <p:notesMasterIdLst>
-    <p:notesMasterId r:id="rId10"/>
+    <p:notesMasterId r:id="rId12"/>
   </p:notesMasterIdLst>
   <p:handoutMasterIdLst>
-    <p:handoutMasterId r:id="rId11"/>
+    <p:handoutMasterId r:id="rId13"/>
   </p:handoutMasterIdLst>
   <p:sldIdLst>
     <p:sldId id="256" r:id="rId2"/>
@@ -17,8 +17,10 @@
     <p:sldId id="291" r:id="rId5"/>
     <p:sldId id="292" r:id="rId6"/>
     <p:sldId id="297" r:id="rId7"/>
-    <p:sldId id="293" r:id="rId8"/>
-    <p:sldId id="288" r:id="rId9"/>
+    <p:sldId id="299" r:id="rId8"/>
+    <p:sldId id="293" r:id="rId9"/>
+    <p:sldId id="298" r:id="rId10"/>
+    <p:sldId id="288" r:id="rId11"/>
   </p:sldIdLst>
   <p:sldSz cx="12192000" cy="6858000"/>
   <p:notesSz cx="12192000" cy="6858000"/>
@@ -233,7 +235,7 @@
           <a:p>
             <a:fld id="{8438F8DC-35B0-48E6-A86E-42F1F08DD00F}" type="datetimeFigureOut">
               <a:rPr lang="es-ES" smtClean="0"/>
-              <a:t>26/02/2026</a:t>
+              <a:t>12/03/2026</a:t>
             </a:fld>
             <a:endParaRPr lang="es-ES"/>
           </a:p>
@@ -410,7 +412,7 @@
           <a:p>
             <a:fld id="{FACBDC12-F39B-4B97-8F4D-6734F9D366FF}" type="datetimeFigureOut">
               <a:rPr lang="es-ES" smtClean="0"/>
-              <a:t>26/02/2026</a:t>
+              <a:t>12/03/2026</a:t>
             </a:fld>
             <a:endParaRPr lang="es-ES"/>
           </a:p>
@@ -1093,6 +1095,114 @@
         <p:cNvPr id="1" name="">
           <a:extLst>
             <a:ext uri="{FF2B5EF4-FFF2-40B4-BE49-F238E27FC236}">
+              <a16:creationId xmlns:a16="http://schemas.microsoft.com/office/drawing/2014/main" id="{B642589C-58F0-5A88-C882-7E92ABD59BE4}"/>
+            </a:ext>
+          </a:extLst>
+        </p:cNvPr>
+        <p:cNvGrpSpPr/>
+        <p:nvPr/>
+      </p:nvGrpSpPr>
+      <p:grpSpPr>
+        <a:xfrm>
+          <a:off x="0" y="0"/>
+          <a:ext cx="0" cy="0"/>
+          <a:chOff x="0" y="0"/>
+          <a:chExt cx="0" cy="0"/>
+        </a:xfrm>
+      </p:grpSpPr>
+      <p:sp>
+        <p:nvSpPr>
+          <p:cNvPr id="2" name="Marcador de imagen de diapositiva 1">
+            <a:extLst>
+              <a:ext uri="{FF2B5EF4-FFF2-40B4-BE49-F238E27FC236}">
+                <a16:creationId xmlns:a16="http://schemas.microsoft.com/office/drawing/2014/main" id="{C614D66F-CB2B-D621-6EAC-AC364AF84E19}"/>
+              </a:ext>
+            </a:extLst>
+          </p:cNvPr>
+          <p:cNvSpPr>
+            <a:spLocks noGrp="1" noRot="1" noChangeAspect="1"/>
+          </p:cNvSpPr>
+          <p:nvPr>
+            <p:ph type="sldImg"/>
+          </p:nvPr>
+        </p:nvSpPr>
+        <p:spPr/>
+      </p:sp>
+      <p:sp>
+        <p:nvSpPr>
+          <p:cNvPr id="3" name="Marcador de notas 2">
+            <a:extLst>
+              <a:ext uri="{FF2B5EF4-FFF2-40B4-BE49-F238E27FC236}">
+                <a16:creationId xmlns:a16="http://schemas.microsoft.com/office/drawing/2014/main" id="{D8A698F5-52F0-C12D-349F-3841C129A3CC}"/>
+              </a:ext>
+            </a:extLst>
+          </p:cNvPr>
+          <p:cNvSpPr>
+            <a:spLocks noGrp="1"/>
+          </p:cNvSpPr>
+          <p:nvPr>
+            <p:ph type="body" idx="1"/>
+          </p:nvPr>
+        </p:nvSpPr>
+        <p:spPr/>
+        <p:txBody>
+          <a:bodyPr/>
+          <a:lstStyle/>
+          <a:p>
+            <a:endParaRPr lang="es-ES" dirty="0"/>
+          </a:p>
+        </p:txBody>
+      </p:sp>
+      <p:sp>
+        <p:nvSpPr>
+          <p:cNvPr id="4" name="Marcador de número de diapositiva 3">
+            <a:extLst>
+              <a:ext uri="{FF2B5EF4-FFF2-40B4-BE49-F238E27FC236}">
+                <a16:creationId xmlns:a16="http://schemas.microsoft.com/office/drawing/2014/main" id="{149A28D2-5619-46C0-5E9B-F090B3CBDF70}"/>
+              </a:ext>
+            </a:extLst>
+          </p:cNvPr>
+          <p:cNvSpPr>
+            <a:spLocks noGrp="1"/>
+          </p:cNvSpPr>
+          <p:nvPr>
+            <p:ph type="sldNum" sz="quarter" idx="5"/>
+          </p:nvPr>
+        </p:nvSpPr>
+        <p:spPr/>
+        <p:txBody>
+          <a:bodyPr/>
+          <a:lstStyle/>
+          <a:p>
+            <a:fld id="{676223B9-C868-4436-87D9-1A3152E1157A}" type="slidenum">
+              <a:rPr lang="es-ES" smtClean="0"/>
+              <a:t>7</a:t>
+            </a:fld>
+            <a:endParaRPr lang="es-ES"/>
+          </a:p>
+        </p:txBody>
+      </p:sp>
+    </p:spTree>
+    <p:extLst>
+      <p:ext uri="{BB962C8B-B14F-4D97-AF65-F5344CB8AC3E}">
+        <p14:creationId xmlns:p14="http://schemas.microsoft.com/office/powerpoint/2010/main" val="1605984538"/>
+      </p:ext>
+    </p:extLst>
+  </p:cSld>
+  <p:clrMapOvr>
+    <a:masterClrMapping/>
+  </p:clrMapOvr>
+</p:notes>
+</file>
+
+<file path=ppt/notesSlides/notesSlide6.xml><?xml version="1.0" encoding="utf-8"?>
+<p:notes xmlns:a="http://schemas.openxmlformats.org/drawingml/2006/main" xmlns:r="http://schemas.openxmlformats.org/officeDocument/2006/relationships" xmlns:p="http://schemas.openxmlformats.org/presentationml/2006/main">
+  <p:cSld>
+    <p:spTree>
+      <p:nvGrpSpPr>
+        <p:cNvPr id="1" name="">
+          <a:extLst>
+            <a:ext uri="{FF2B5EF4-FFF2-40B4-BE49-F238E27FC236}">
               <a16:creationId xmlns:a16="http://schemas.microsoft.com/office/drawing/2014/main" id="{7B023B86-D15F-9CD8-C5EA-3EAAD8BACCF7}"/>
             </a:ext>
           </a:extLst>
@@ -1174,7 +1284,7 @@
           <a:p>
             <a:fld id="{676223B9-C868-4436-87D9-1A3152E1157A}" type="slidenum">
               <a:rPr lang="es-ES" smtClean="0"/>
-              <a:t>7</a:t>
+              <a:t>8</a:t>
             </a:fld>
             <a:endParaRPr lang="es-ES"/>
           </a:p>
@@ -1184,6 +1294,114 @@
     <p:extLst>
       <p:ext uri="{BB962C8B-B14F-4D97-AF65-F5344CB8AC3E}">
         <p14:creationId xmlns:p14="http://schemas.microsoft.com/office/powerpoint/2010/main" val="2917382716"/>
+      </p:ext>
+    </p:extLst>
+  </p:cSld>
+  <p:clrMapOvr>
+    <a:masterClrMapping/>
+  </p:clrMapOvr>
+</p:notes>
+</file>
+
+<file path=ppt/notesSlides/notesSlide7.xml><?xml version="1.0" encoding="utf-8"?>
+<p:notes xmlns:a="http://schemas.openxmlformats.org/drawingml/2006/main" xmlns:r="http://schemas.openxmlformats.org/officeDocument/2006/relationships" xmlns:p="http://schemas.openxmlformats.org/presentationml/2006/main">
+  <p:cSld>
+    <p:spTree>
+      <p:nvGrpSpPr>
+        <p:cNvPr id="1" name="">
+          <a:extLst>
+            <a:ext uri="{FF2B5EF4-FFF2-40B4-BE49-F238E27FC236}">
+              <a16:creationId xmlns:a16="http://schemas.microsoft.com/office/drawing/2014/main" id="{6BF3712D-062B-09DC-1D35-DE1C78F4B892}"/>
+            </a:ext>
+          </a:extLst>
+        </p:cNvPr>
+        <p:cNvGrpSpPr/>
+        <p:nvPr/>
+      </p:nvGrpSpPr>
+      <p:grpSpPr>
+        <a:xfrm>
+          <a:off x="0" y="0"/>
+          <a:ext cx="0" cy="0"/>
+          <a:chOff x="0" y="0"/>
+          <a:chExt cx="0" cy="0"/>
+        </a:xfrm>
+      </p:grpSpPr>
+      <p:sp>
+        <p:nvSpPr>
+          <p:cNvPr id="2" name="Marcador de imagen de diapositiva 1">
+            <a:extLst>
+              <a:ext uri="{FF2B5EF4-FFF2-40B4-BE49-F238E27FC236}">
+                <a16:creationId xmlns:a16="http://schemas.microsoft.com/office/drawing/2014/main" id="{05B89BEE-E2E8-7260-2635-8E6DC5E43911}"/>
+              </a:ext>
+            </a:extLst>
+          </p:cNvPr>
+          <p:cNvSpPr>
+            <a:spLocks noGrp="1" noRot="1" noChangeAspect="1"/>
+          </p:cNvSpPr>
+          <p:nvPr>
+            <p:ph type="sldImg"/>
+          </p:nvPr>
+        </p:nvSpPr>
+        <p:spPr/>
+      </p:sp>
+      <p:sp>
+        <p:nvSpPr>
+          <p:cNvPr id="3" name="Marcador de notas 2">
+            <a:extLst>
+              <a:ext uri="{FF2B5EF4-FFF2-40B4-BE49-F238E27FC236}">
+                <a16:creationId xmlns:a16="http://schemas.microsoft.com/office/drawing/2014/main" id="{628A0B49-0BAC-A109-895B-C0D5BB678AA1}"/>
+              </a:ext>
+            </a:extLst>
+          </p:cNvPr>
+          <p:cNvSpPr>
+            <a:spLocks noGrp="1"/>
+          </p:cNvSpPr>
+          <p:nvPr>
+            <p:ph type="body" idx="1"/>
+          </p:nvPr>
+        </p:nvSpPr>
+        <p:spPr/>
+        <p:txBody>
+          <a:bodyPr/>
+          <a:lstStyle/>
+          <a:p>
+            <a:endParaRPr lang="es-ES" dirty="0"/>
+          </a:p>
+        </p:txBody>
+      </p:sp>
+      <p:sp>
+        <p:nvSpPr>
+          <p:cNvPr id="4" name="Marcador de número de diapositiva 3">
+            <a:extLst>
+              <a:ext uri="{FF2B5EF4-FFF2-40B4-BE49-F238E27FC236}">
+                <a16:creationId xmlns:a16="http://schemas.microsoft.com/office/drawing/2014/main" id="{5C98A4B5-4AD3-4B91-D03A-53C86FA7DC96}"/>
+              </a:ext>
+            </a:extLst>
+          </p:cNvPr>
+          <p:cNvSpPr>
+            <a:spLocks noGrp="1"/>
+          </p:cNvSpPr>
+          <p:nvPr>
+            <p:ph type="sldNum" sz="quarter" idx="5"/>
+          </p:nvPr>
+        </p:nvSpPr>
+        <p:spPr/>
+        <p:txBody>
+          <a:bodyPr/>
+          <a:lstStyle/>
+          <a:p>
+            <a:fld id="{676223B9-C868-4436-87D9-1A3152E1157A}" type="slidenum">
+              <a:rPr lang="es-ES" smtClean="0"/>
+              <a:t>9</a:t>
+            </a:fld>
+            <a:endParaRPr lang="es-ES"/>
+          </a:p>
+        </p:txBody>
+      </p:sp>
+    </p:spTree>
+    <p:extLst>
+      <p:ext uri="{BB962C8B-B14F-4D97-AF65-F5344CB8AC3E}">
+        <p14:creationId xmlns:p14="http://schemas.microsoft.com/office/powerpoint/2010/main" val="3343820094"/>
       </p:ext>
     </p:extLst>
   </p:cSld>
@@ -2678,7 +2896,7 @@
         <p:spPr>
           <a:xfrm>
             <a:off x="2749676" y="5610250"/>
-            <a:ext cx="8223124" cy="289823"/>
+            <a:ext cx="8223124" cy="579646"/>
           </a:xfrm>
           <a:prstGeom prst="rect">
             <a:avLst/>
@@ -2710,7 +2928,31 @@
                 <a:latin typeface="Arial"/>
                 <a:cs typeface="Arial"/>
               </a:rPr>
-              <a:t>: José Alberto Peña Cruz , Pablo de Manuel Vicente </a:t>
+              <a:t>: José Alberto Peña Cruz , Pablo de Manuel Vicente</a:t>
+            </a:r>
+          </a:p>
+          <a:p>
+            <a:pPr marL="12700">
+              <a:lnSpc>
+                <a:spcPct val="100000"/>
+              </a:lnSpc>
+              <a:spcBef>
+                <a:spcPts val="100"/>
+              </a:spcBef>
+            </a:pPr>
+            <a:r>
+              <a:rPr lang="es-ES" spc="165" dirty="0" err="1">
+                <a:latin typeface="Arial"/>
+                <a:cs typeface="Arial"/>
+              </a:rPr>
+              <a:t>Group</a:t>
+            </a:r>
+            <a:r>
+              <a:rPr lang="es-ES" spc="165" dirty="0">
+                <a:latin typeface="Arial"/>
+                <a:cs typeface="Arial"/>
+              </a:rPr>
+              <a:t>: B1 </a:t>
             </a:r>
             <a:endParaRPr sz="1800" dirty="0">
               <a:latin typeface="Arial"/>
@@ -2772,6 +3014,159 @@
             <a:fld id="{B6F15528-21DE-4FAA-801E-634DDDAF4B2B}" type="slidenum">
               <a:rPr lang="es-ES" smtClean="0"/>
               <a:t>1</a:t>
+            </a:fld>
+            <a:endParaRPr lang="es-ES"/>
+          </a:p>
+        </p:txBody>
+      </p:sp>
+    </p:spTree>
+  </p:cSld>
+  <p:clrMapOvr>
+    <a:masterClrMapping/>
+  </p:clrMapOvr>
+</p:sld>
+</file>
+
+<file path=ppt/slides/slide10.xml><?xml version="1.0" encoding="utf-8"?>
+<p:sld xmlns:a="http://schemas.openxmlformats.org/drawingml/2006/main" xmlns:r="http://schemas.openxmlformats.org/officeDocument/2006/relationships" xmlns:p="http://schemas.openxmlformats.org/presentationml/2006/main">
+  <p:cSld>
+    <p:spTree>
+      <p:nvGrpSpPr>
+        <p:cNvPr id="1" name=""/>
+        <p:cNvGrpSpPr/>
+        <p:nvPr/>
+      </p:nvGrpSpPr>
+      <p:grpSpPr>
+        <a:xfrm>
+          <a:off x="0" y="0"/>
+          <a:ext cx="0" cy="0"/>
+          <a:chOff x="0" y="0"/>
+          <a:chExt cx="0" cy="0"/>
+        </a:xfrm>
+      </p:grpSpPr>
+      <p:sp>
+        <p:nvSpPr>
+          <p:cNvPr id="3" name="object 3"/>
+          <p:cNvSpPr/>
+          <p:nvPr/>
+        </p:nvSpPr>
+        <p:spPr>
+          <a:xfrm>
+            <a:off x="3945635" y="2636520"/>
+            <a:ext cx="8246363" cy="1584959"/>
+          </a:xfrm>
+          <a:prstGeom prst="rect">
+            <a:avLst/>
+          </a:prstGeom>
+          <a:blipFill>
+            <a:blip r:embed="rId2" cstate="print"/>
+            <a:stretch>
+              <a:fillRect/>
+            </a:stretch>
+          </a:blipFill>
+        </p:spPr>
+        <p:txBody>
+          <a:bodyPr wrap="square" lIns="0" tIns="0" rIns="0" bIns="0" rtlCol="0"/>
+          <a:lstStyle/>
+          <a:p>
+            <a:endParaRPr/>
+          </a:p>
+        </p:txBody>
+      </p:sp>
+      <p:sp>
+        <p:nvSpPr>
+          <p:cNvPr id="4" name="object 4"/>
+          <p:cNvSpPr txBox="1">
+            <a:spLocks noGrp="1"/>
+          </p:cNvSpPr>
+          <p:nvPr>
+            <p:ph type="title"/>
+          </p:nvPr>
+        </p:nvSpPr>
+        <p:spPr>
+          <a:xfrm>
+            <a:off x="4513326" y="3165729"/>
+            <a:ext cx="2233295" cy="513715"/>
+          </a:xfrm>
+          <a:prstGeom prst="rect">
+            <a:avLst/>
+          </a:prstGeom>
+        </p:spPr>
+        <p:txBody>
+          <a:bodyPr vert="horz" wrap="square" lIns="0" tIns="13335" rIns="0" bIns="0" rtlCol="0">
+            <a:spAutoFit/>
+          </a:bodyPr>
+          <a:lstStyle/>
+          <a:p>
+            <a:pPr marL="12700">
+              <a:lnSpc>
+                <a:spcPct val="100000"/>
+              </a:lnSpc>
+              <a:spcBef>
+                <a:spcPts val="105"/>
+              </a:spcBef>
+            </a:pPr>
+            <a:r>
+              <a:rPr sz="3200" b="1" spc="-5" dirty="0">
+                <a:solidFill>
+                  <a:srgbClr val="FFFFFF"/>
+                </a:solidFill>
+                <a:latin typeface="Lucida Sans"/>
+                <a:cs typeface="Lucida Sans"/>
+              </a:rPr>
+              <a:t>Thank</a:t>
+            </a:r>
+            <a:r>
+              <a:rPr sz="3200" b="1" spc="-55" dirty="0">
+                <a:solidFill>
+                  <a:srgbClr val="FFFFFF"/>
+                </a:solidFill>
+                <a:latin typeface="Lucida Sans"/>
+                <a:cs typeface="Lucida Sans"/>
+              </a:rPr>
+              <a:t> </a:t>
+            </a:r>
+            <a:r>
+              <a:rPr sz="3200" b="1" dirty="0">
+                <a:solidFill>
+                  <a:srgbClr val="FFFFFF"/>
+                </a:solidFill>
+                <a:latin typeface="Lucida Sans"/>
+                <a:cs typeface="Lucida Sans"/>
+              </a:rPr>
+              <a:t>you</a:t>
+            </a:r>
+            <a:endParaRPr sz="3200">
+              <a:latin typeface="Lucida Sans"/>
+              <a:cs typeface="Lucida Sans"/>
+            </a:endParaRPr>
+          </a:p>
+        </p:txBody>
+      </p:sp>
+      <p:sp>
+        <p:nvSpPr>
+          <p:cNvPr id="5" name="Marcador de número de diapositiva 4">
+            <a:extLst>
+              <a:ext uri="{FF2B5EF4-FFF2-40B4-BE49-F238E27FC236}">
+                <a16:creationId xmlns:a16="http://schemas.microsoft.com/office/drawing/2014/main" id="{B052DA19-AD24-7D24-2AE9-51F8F5A7F5E0}"/>
+              </a:ext>
+            </a:extLst>
+          </p:cNvPr>
+          <p:cNvSpPr>
+            <a:spLocks noGrp="1"/>
+          </p:cNvSpPr>
+          <p:nvPr>
+            <p:ph type="sldNum" sz="quarter" idx="7"/>
+          </p:nvPr>
+        </p:nvSpPr>
+        <p:spPr/>
+        <p:txBody>
+          <a:bodyPr/>
+          <a:lstStyle/>
+          <a:p>
+            <a:fld id="{B6F15528-21DE-4FAA-801E-634DDDAF4B2B}" type="slidenum">
+              <a:rPr lang="es-ES" smtClean="0"/>
+              <a:t>10</a:t>
             </a:fld>
             <a:endParaRPr lang="es-ES"/>
           </a:p>
@@ -6931,7 +7326,7 @@
         </p:blipFill>
         <p:spPr>
           <a:xfrm>
-            <a:off x="3276600" y="1510598"/>
+            <a:off x="3901440" y="1496632"/>
             <a:ext cx="5410200" cy="3149509"/>
           </a:xfrm>
           <a:prstGeom prst="rect">
@@ -7156,8 +7551,8 @@
           </a:p>
         </p:txBody>
       </p:sp>
-      <mc:AlternateContent xmlns:mc="http://schemas.openxmlformats.org/markup-compatibility/2006" xmlns:a14="http://schemas.microsoft.com/office/drawing/2010/main">
-        <mc:Choice Requires="a14">
+      <mc:AlternateContent xmlns:mc="http://schemas.openxmlformats.org/markup-compatibility/2006">
+        <mc:Choice xmlns:a14="http://schemas.microsoft.com/office/drawing/2010/main" Requires="a14">
           <p:sp>
             <p:nvSpPr>
               <p:cNvPr id="2" name="CuadroTexto 1">
@@ -7173,7 +7568,7 @@
             <p:spPr>
               <a:xfrm>
                 <a:off x="609441" y="4860334"/>
-                <a:ext cx="11198542" cy="1361911"/>
+                <a:ext cx="11198542" cy="1478738"/>
               </a:xfrm>
               <a:prstGeom prst="rect">
                 <a:avLst/>
@@ -7197,7 +7592,7 @@
               <a:p>
                 <a:pPr algn="just"/>
                 <a:r>
-                  <a:rPr lang="en-US" sz="1200" dirty="0">
+                  <a:rPr lang="en-US" sz="1200" b="1" dirty="0">
                     <a:latin typeface="Arial" panose="020B0604020202020204" pitchFamily="34" charset="0"/>
                     <a:cs typeface="Arial" panose="020B0604020202020204" pitchFamily="34" charset="0"/>
                   </a:rPr>
@@ -7210,7 +7605,7 @@
                         <m:begChr m:val="{"/>
                         <m:endChr m:val=""/>
                         <m:ctrlPr>
-                          <a:rPr lang="es-ES" sz="1200" b="0" i="1" smtClean="0">
+                          <a:rPr lang="es-ES" sz="1200" b="1" i="1" smtClean="0">
                             <a:latin typeface="Cambria Math" panose="02040503050406030204" pitchFamily="18" charset="0"/>
                             <a:cs typeface="Arial" panose="020B0604020202020204" pitchFamily="34" charset="0"/>
                           </a:rPr>
@@ -7220,7 +7615,7 @@
                         <m:eqArr>
                           <m:eqArrPr>
                             <m:ctrlPr>
-                              <a:rPr lang="es-ES" sz="1200" b="0" i="1" smtClean="0">
+                              <a:rPr lang="es-ES" sz="1200" b="1" i="1" smtClean="0">
                                 <a:latin typeface="Cambria Math" panose="02040503050406030204" pitchFamily="18" charset="0"/>
                                 <a:cs typeface="Arial" panose="020B0604020202020204" pitchFamily="34" charset="0"/>
                               </a:rPr>
@@ -7230,7 +7625,7 @@
                             <m:sSub>
                               <m:sSubPr>
                                 <m:ctrlPr>
-                                  <a:rPr lang="es-ES" sz="1200" b="0" i="1" smtClean="0">
+                                  <a:rPr lang="es-ES" sz="1200" b="1" i="1" smtClean="0">
                                     <a:latin typeface="Cambria Math" panose="02040503050406030204" pitchFamily="18" charset="0"/>
                                     <a:cs typeface="Arial" panose="020B0604020202020204" pitchFamily="34" charset="0"/>
                                   </a:rPr>
@@ -7238,25 +7633,25 @@
                               </m:sSubPr>
                               <m:e>
                                 <m:r>
-                                  <a:rPr lang="es-ES" sz="1200" b="0" i="1" smtClean="0">
+                                  <a:rPr lang="es-ES" sz="1200" b="1" i="1" smtClean="0">
                                     <a:latin typeface="Cambria Math" panose="02040503050406030204" pitchFamily="18" charset="0"/>
                                     <a:cs typeface="Arial" panose="020B0604020202020204" pitchFamily="34" charset="0"/>
                                   </a:rPr>
-                                  <m:t>𝑛</m:t>
+                                  <m:t>𝒏</m:t>
                                 </m:r>
                               </m:e>
                               <m:sub>
                                 <m:r>
-                                  <a:rPr lang="es-ES" sz="1200" b="0" i="1" smtClean="0">
+                                  <a:rPr lang="es-ES" sz="1200" b="1" i="1" smtClean="0">
                                     <a:latin typeface="Cambria Math" panose="02040503050406030204" pitchFamily="18" charset="0"/>
                                     <a:cs typeface="Arial" panose="020B0604020202020204" pitchFamily="34" charset="0"/>
                                   </a:rPr>
-                                  <m:t>𝑒𝑓𝑓</m:t>
+                                  <m:t>𝒆𝒇𝒇</m:t>
                                 </m:r>
                               </m:sub>
                             </m:sSub>
                             <m:r>
-                              <a:rPr lang="es-ES" sz="1200" b="0" i="1" smtClean="0">
+                              <a:rPr lang="es-ES" sz="1200" b="1" i="1" smtClean="0">
                                 <a:latin typeface="Cambria Math" panose="02040503050406030204" pitchFamily="18" charset="0"/>
                                 <a:cs typeface="Arial" panose="020B0604020202020204" pitchFamily="34" charset="0"/>
                               </a:rPr>
@@ -7265,7 +7660,7 @@
                             <m:sSub>
                               <m:sSubPr>
                                 <m:ctrlPr>
-                                  <a:rPr lang="es-ES" sz="1200" b="0" i="1" smtClean="0">
+                                  <a:rPr lang="es-ES" sz="1200" b="1" i="1" smtClean="0">
                                     <a:latin typeface="Cambria Math" panose="02040503050406030204" pitchFamily="18" charset="0"/>
                                     <a:cs typeface="Arial" panose="020B0604020202020204" pitchFamily="34" charset="0"/>
                                   </a:rPr>
@@ -7273,20 +7668,20 @@
                               </m:sSubPr>
                               <m:e>
                                 <m:r>
-                                  <a:rPr lang="es-ES" sz="1200" b="0" i="1" smtClean="0">
+                                  <a:rPr lang="es-ES" sz="1200" b="1" i="1" smtClean="0">
                                     <a:latin typeface="Cambria Math" panose="02040503050406030204" pitchFamily="18" charset="0"/>
                                     <a:cs typeface="Arial" panose="020B0604020202020204" pitchFamily="34" charset="0"/>
                                   </a:rPr>
-                                  <m:t>𝑛</m:t>
+                                  <m:t>𝒏</m:t>
                                 </m:r>
                               </m:e>
                               <m:sub>
                                 <m:r>
-                                  <a:rPr lang="es-ES" sz="1200" b="0" i="1" smtClean="0">
+                                  <a:rPr lang="es-ES" sz="1200" b="1" i="1" smtClean="0">
                                     <a:latin typeface="Cambria Math" panose="02040503050406030204" pitchFamily="18" charset="0"/>
                                     <a:cs typeface="Arial" panose="020B0604020202020204" pitchFamily="34" charset="0"/>
                                   </a:rPr>
-                                  <m:t>1</m:t>
+                                  <m:t>𝟏</m:t>
                                 </m:r>
                               </m:sub>
                             </m:sSub>
@@ -7295,7 +7690,7 @@
                             <m:sSub>
                               <m:sSubPr>
                                 <m:ctrlPr>
-                                  <a:rPr lang="es-ES" sz="1200" b="0" i="1" smtClean="0">
+                                  <a:rPr lang="es-ES" sz="1200" b="1" i="1" smtClean="0">
                                     <a:latin typeface="Cambria Math" panose="02040503050406030204" pitchFamily="18" charset="0"/>
                                     <a:cs typeface="Arial" panose="020B0604020202020204" pitchFamily="34" charset="0"/>
                                   </a:rPr>
@@ -7303,25 +7698,25 @@
                               </m:sSubPr>
                               <m:e>
                                 <m:r>
-                                  <a:rPr lang="es-ES" sz="1200" b="0" i="1" smtClean="0">
+                                  <a:rPr lang="es-ES" sz="1200" b="1" i="1" smtClean="0">
                                     <a:latin typeface="Cambria Math" panose="02040503050406030204" pitchFamily="18" charset="0"/>
                                     <a:cs typeface="Arial" panose="020B0604020202020204" pitchFamily="34" charset="0"/>
                                   </a:rPr>
-                                  <m:t>𝑛</m:t>
+                                  <m:t>𝒏</m:t>
                                 </m:r>
                               </m:e>
                               <m:sub>
                                 <m:r>
-                                  <a:rPr lang="es-ES" sz="1200" b="0" i="1" smtClean="0">
+                                  <a:rPr lang="es-ES" sz="1200" b="1" i="1" smtClean="0">
                                     <a:latin typeface="Cambria Math" panose="02040503050406030204" pitchFamily="18" charset="0"/>
                                     <a:cs typeface="Arial" panose="020B0604020202020204" pitchFamily="34" charset="0"/>
                                   </a:rPr>
-                                  <m:t>𝑔</m:t>
+                                  <m:t>𝒈</m:t>
                                 </m:r>
                               </m:sub>
                             </m:sSub>
                             <m:r>
-                              <a:rPr lang="es-ES" sz="1200" b="0" i="1" smtClean="0">
+                              <a:rPr lang="es-ES" sz="1200" b="1" i="1" smtClean="0">
                                 <a:latin typeface="Cambria Math" panose="02040503050406030204" pitchFamily="18" charset="0"/>
                                 <a:cs typeface="Arial" panose="020B0604020202020204" pitchFamily="34" charset="0"/>
                               </a:rPr>
@@ -7330,7 +7725,7 @@
                             <m:sSub>
                               <m:sSubPr>
                                 <m:ctrlPr>
-                                  <a:rPr lang="es-ES" sz="1200" b="0" i="1" smtClean="0">
+                                  <a:rPr lang="es-ES" sz="1200" b="1" i="1" smtClean="0">
                                     <a:latin typeface="Cambria Math" panose="02040503050406030204" pitchFamily="18" charset="0"/>
                                     <a:cs typeface="Arial" panose="020B0604020202020204" pitchFamily="34" charset="0"/>
                                   </a:rPr>
@@ -7338,25 +7733,25 @@
                               </m:sSubPr>
                               <m:e>
                                 <m:r>
-                                  <a:rPr lang="es-ES" sz="1200" b="0" i="1" smtClean="0">
+                                  <a:rPr lang="es-ES" sz="1200" b="1" i="1" smtClean="0">
                                     <a:latin typeface="Cambria Math" panose="02040503050406030204" pitchFamily="18" charset="0"/>
                                     <a:cs typeface="Arial" panose="020B0604020202020204" pitchFamily="34" charset="0"/>
                                   </a:rPr>
-                                  <m:t>𝑛</m:t>
+                                  <m:t>𝒏</m:t>
                                 </m:r>
                               </m:e>
                               <m:sub>
                                 <m:r>
-                                  <a:rPr lang="es-ES" sz="1200" b="0" i="1" smtClean="0">
+                                  <a:rPr lang="es-ES" sz="1200" b="1" i="1" smtClean="0">
                                     <a:latin typeface="Cambria Math" panose="02040503050406030204" pitchFamily="18" charset="0"/>
                                     <a:cs typeface="Arial" panose="020B0604020202020204" pitchFamily="34" charset="0"/>
                                   </a:rPr>
-                                  <m:t>1</m:t>
+                                  <m:t>𝟏</m:t>
                                 </m:r>
                               </m:sub>
                             </m:sSub>
                             <m:r>
-                              <a:rPr lang="es-ES" sz="1200" b="0" i="1" smtClean="0">
+                              <a:rPr lang="es-ES" sz="1200" b="1" i="1" smtClean="0">
                                 <a:latin typeface="Cambria Math" panose="02040503050406030204" pitchFamily="18" charset="0"/>
                                 <a:cs typeface="Arial" panose="020B0604020202020204" pitchFamily="34" charset="0"/>
                               </a:rPr>
@@ -7365,7 +7760,7 @@
                             <m:sSub>
                               <m:sSubPr>
                                 <m:ctrlPr>
-                                  <a:rPr lang="es-ES" sz="1200" b="0" i="1" smtClean="0">
+                                  <a:rPr lang="es-ES" sz="1200" b="1" i="1" smtClean="0">
                                     <a:latin typeface="Cambria Math" panose="02040503050406030204" pitchFamily="18" charset="0"/>
                                     <a:cs typeface="Arial" panose="020B0604020202020204" pitchFamily="34" charset="0"/>
                                   </a:rPr>
@@ -7373,27 +7768,27 @@
                               </m:sSubPr>
                               <m:e>
                                 <m:r>
-                                  <a:rPr lang="es-ES" sz="1200" b="0" i="1" smtClean="0">
+                                  <a:rPr lang="es-ES" sz="1200" b="1" i="1" smtClean="0">
                                     <a:latin typeface="Cambria Math" panose="02040503050406030204" pitchFamily="18" charset="0"/>
                                     <a:cs typeface="Arial" panose="020B0604020202020204" pitchFamily="34" charset="0"/>
                                   </a:rPr>
-                                  <m:t>𝑛</m:t>
+                                  <m:t>𝒏</m:t>
                                 </m:r>
                               </m:e>
                               <m:sub>
                                 <m:r>
-                                  <a:rPr lang="es-ES" sz="1200" b="0" i="1" smtClean="0">
+                                  <a:rPr lang="es-ES" sz="1200" b="1" i="1" smtClean="0">
                                     <a:latin typeface="Cambria Math" panose="02040503050406030204" pitchFamily="18" charset="0"/>
                                     <a:cs typeface="Arial" panose="020B0604020202020204" pitchFamily="34" charset="0"/>
                                   </a:rPr>
-                                  <m:t>2</m:t>
+                                  <m:t>𝟐</m:t>
                                 </m:r>
                               </m:sub>
                             </m:sSub>
                             <m:sSub>
                               <m:sSubPr>
                                 <m:ctrlPr>
-                                  <a:rPr lang="es-ES" sz="1200" b="0" i="1" smtClean="0">
+                                  <a:rPr lang="es-ES" sz="1200" b="1" i="1" smtClean="0">
                                     <a:latin typeface="Cambria Math" panose="02040503050406030204" pitchFamily="18" charset="0"/>
                                     <a:cs typeface="Arial" panose="020B0604020202020204" pitchFamily="34" charset="0"/>
                                   </a:rPr>
@@ -7401,34 +7796,34 @@
                               </m:sSubPr>
                               <m:e>
                                 <m:r>
-                                  <a:rPr lang="es-ES" sz="1200" b="0" i="1" smtClean="0">
+                                  <a:rPr lang="es-ES" sz="1200" b="1" i="1" smtClean="0">
                                     <a:latin typeface="Cambria Math" panose="02040503050406030204" pitchFamily="18" charset="0"/>
                                     <a:cs typeface="Arial" panose="020B0604020202020204" pitchFamily="34" charset="0"/>
                                   </a:rPr>
-                                  <m:t>𝜆</m:t>
+                                  <m:t>𝝀</m:t>
                                 </m:r>
                               </m:e>
                               <m:sub>
                                 <m:r>
-                                  <a:rPr lang="es-ES" sz="1200" b="0" i="1" smtClean="0">
+                                  <a:rPr lang="es-ES" sz="1200" b="1" i="1" smtClean="0">
                                     <a:latin typeface="Cambria Math" panose="02040503050406030204" pitchFamily="18" charset="0"/>
                                     <a:cs typeface="Arial" panose="020B0604020202020204" pitchFamily="34" charset="0"/>
                                   </a:rPr>
-                                  <m:t>0</m:t>
+                                  <m:t>𝟎</m:t>
                                 </m:r>
                               </m:sub>
                             </m:sSub>
                           </m:e>
                           <m:e>
                             <m:r>
-                              <a:rPr lang="es-ES" sz="1200" b="0" i="1" smtClean="0">
+                              <a:rPr lang="es-ES" sz="1200" b="1" i="1" smtClean="0">
                                 <a:latin typeface="Cambria Math" panose="02040503050406030204" pitchFamily="18" charset="0"/>
                                 <a:cs typeface="Arial" panose="020B0604020202020204" pitchFamily="34" charset="0"/>
                               </a:rPr>
-                              <m:t>𝐷</m:t>
+                              <m:t>𝑫</m:t>
                             </m:r>
                             <m:r>
-                              <a:rPr lang="es-ES" sz="1200" b="0" i="1" smtClean="0">
+                              <a:rPr lang="es-ES" sz="1200" b="1" i="1" smtClean="0">
                                 <a:latin typeface="Cambria Math" panose="02040503050406030204" pitchFamily="18" charset="0"/>
                                 <a:cs typeface="Arial" panose="020B0604020202020204" pitchFamily="34" charset="0"/>
                               </a:rPr>
@@ -7437,7 +7832,7 @@
                             <m:f>
                               <m:fPr>
                                 <m:ctrlPr>
-                                  <a:rPr lang="es-ES" sz="1200" b="0" i="1" smtClean="0">
+                                  <a:rPr lang="es-ES" sz="1200" b="1" i="1" smtClean="0">
                                     <a:latin typeface="Cambria Math" panose="02040503050406030204" pitchFamily="18" charset="0"/>
                                     <a:cs typeface="Arial" panose="020B0604020202020204" pitchFamily="34" charset="0"/>
                                   </a:rPr>
@@ -7445,16 +7840,16 @@
                               </m:fPr>
                               <m:num>
                                 <m:r>
-                                  <a:rPr lang="es-ES" sz="1200" b="0" i="1" smtClean="0">
+                                  <a:rPr lang="es-ES" sz="1200" b="1" i="1" smtClean="0">
                                     <a:latin typeface="Cambria Math" panose="02040503050406030204" pitchFamily="18" charset="0"/>
                                     <a:cs typeface="Arial" panose="020B0604020202020204" pitchFamily="34" charset="0"/>
                                   </a:rPr>
-                                  <m:t>2</m:t>
+                                  <m:t>𝟐</m:t>
                                 </m:r>
                                 <m:sSub>
                                   <m:sSubPr>
                                     <m:ctrlPr>
-                                      <a:rPr lang="es-ES" sz="1200" b="0" i="1" smtClean="0">
+                                      <a:rPr lang="es-ES" sz="1200" b="1" i="1" smtClean="0">
                                         <a:latin typeface="Cambria Math" panose="02040503050406030204" pitchFamily="18" charset="0"/>
                                         <a:cs typeface="Arial" panose="020B0604020202020204" pitchFamily="34" charset="0"/>
                                       </a:rPr>
@@ -7462,27 +7857,27 @@
                                   </m:sSubPr>
                                   <m:e>
                                     <m:r>
-                                      <a:rPr lang="es-ES" sz="1200" b="0" i="1" smtClean="0">
+                                      <a:rPr lang="es-ES" sz="1200" b="1" i="1" smtClean="0">
                                         <a:latin typeface="Cambria Math" panose="02040503050406030204" pitchFamily="18" charset="0"/>
                                         <a:cs typeface="Arial" panose="020B0604020202020204" pitchFamily="34" charset="0"/>
                                       </a:rPr>
-                                      <m:t>𝜆</m:t>
+                                      <m:t>𝝀</m:t>
                                     </m:r>
                                   </m:e>
                                   <m:sub>
                                     <m:r>
-                                      <a:rPr lang="es-ES" sz="1200" b="0" i="1" smtClean="0">
+                                      <a:rPr lang="es-ES" sz="1200" b="1" i="1" smtClean="0">
                                         <a:latin typeface="Cambria Math" panose="02040503050406030204" pitchFamily="18" charset="0"/>
                                         <a:cs typeface="Arial" panose="020B0604020202020204" pitchFamily="34" charset="0"/>
                                       </a:rPr>
-                                      <m:t>0</m:t>
+                                      <m:t>𝟎</m:t>
                                     </m:r>
                                   </m:sub>
                                 </m:sSub>
                                 <m:sSub>
                                   <m:sSubPr>
                                     <m:ctrlPr>
-                                      <a:rPr lang="es-ES" sz="1200" b="0" i="1" smtClean="0">
+                                      <a:rPr lang="es-ES" sz="1200" b="1" i="1" smtClean="0">
                                         <a:latin typeface="Cambria Math" panose="02040503050406030204" pitchFamily="18" charset="0"/>
                                         <a:cs typeface="Arial" panose="020B0604020202020204" pitchFamily="34" charset="0"/>
                                       </a:rPr>
@@ -7490,31 +7885,31 @@
                                   </m:sSubPr>
                                   <m:e>
                                     <m:r>
-                                      <a:rPr lang="es-ES" sz="1200" b="0" i="1" smtClean="0">
+                                      <a:rPr lang="es-ES" sz="1200" b="1" i="1" smtClean="0">
                                         <a:latin typeface="Cambria Math" panose="02040503050406030204" pitchFamily="18" charset="0"/>
                                         <a:cs typeface="Arial" panose="020B0604020202020204" pitchFamily="34" charset="0"/>
                                       </a:rPr>
-                                      <m:t>𝑛</m:t>
+                                      <m:t>𝒏</m:t>
                                     </m:r>
                                   </m:e>
                                   <m:sub>
                                     <m:r>
-                                      <a:rPr lang="es-ES" sz="1200" b="0" i="1" smtClean="0">
+                                      <a:rPr lang="es-ES" sz="1200" b="1" i="1" smtClean="0">
                                         <a:latin typeface="Cambria Math" panose="02040503050406030204" pitchFamily="18" charset="0"/>
                                         <a:cs typeface="Arial" panose="020B0604020202020204" pitchFamily="34" charset="0"/>
                                       </a:rPr>
-                                      <m:t>3</m:t>
+                                      <m:t>𝟑</m:t>
                                     </m:r>
                                   </m:sub>
                                 </m:sSub>
                               </m:num>
                               <m:den>
                                 <m:r>
-                                  <a:rPr lang="es-ES" sz="1200" b="0" i="1" smtClean="0">
+                                  <a:rPr lang="es-ES" sz="1200" b="1" i="1" smtClean="0">
                                     <a:latin typeface="Cambria Math" panose="02040503050406030204" pitchFamily="18" charset="0"/>
                                     <a:cs typeface="Arial" panose="020B0604020202020204" pitchFamily="34" charset="0"/>
                                   </a:rPr>
-                                  <m:t>𝑐</m:t>
+                                  <m:t>𝒄</m:t>
                                 </m:r>
                               </m:den>
                             </m:f>
@@ -7523,7 +7918,7 @@
                                 <m:begChr m:val="["/>
                                 <m:endChr m:val="]"/>
                                 <m:ctrlPr>
-                                  <a:rPr lang="es-ES" sz="1200" b="0" i="1" smtClean="0">
+                                  <a:rPr lang="es-ES" sz="1200" b="1" i="1" smtClean="0">
                                     <a:latin typeface="Cambria Math" panose="02040503050406030204" pitchFamily="18" charset="0"/>
                                     <a:cs typeface="Arial" panose="020B0604020202020204" pitchFamily="34" charset="0"/>
                                   </a:rPr>
@@ -7533,7 +7928,7 @@
                                 <m:f>
                                   <m:fPr>
                                     <m:ctrlPr>
-                                      <a:rPr lang="es-ES" sz="1200" b="0" i="1" smtClean="0">
+                                      <a:rPr lang="es-ES" sz="1200" b="1" i="1" smtClean="0">
                                         <a:latin typeface="Cambria Math" panose="02040503050406030204" pitchFamily="18" charset="0"/>
                                         <a:cs typeface="Arial" panose="020B0604020202020204" pitchFamily="34" charset="0"/>
                                       </a:rPr>
@@ -7543,7 +7938,7 @@
                                     <m:sSup>
                                       <m:sSupPr>
                                         <m:ctrlPr>
-                                          <a:rPr lang="es-ES" sz="1200" b="0" i="1" smtClean="0">
+                                          <a:rPr lang="es-ES" sz="1200" b="1" i="1" smtClean="0">
                                             <a:latin typeface="Cambria Math" panose="02040503050406030204" pitchFamily="18" charset="0"/>
                                             <a:cs typeface="Arial" panose="020B0604020202020204" pitchFamily="34" charset="0"/>
                                           </a:rPr>
@@ -7551,31 +7946,31 @@
                                       </m:sSupPr>
                                       <m:e>
                                         <m:r>
-                                          <a:rPr lang="es-ES" sz="1200" b="0" i="1" smtClean="0">
+                                          <a:rPr lang="es-ES" sz="1200" b="1" i="1" smtClean="0">
                                             <a:latin typeface="Cambria Math" panose="02040503050406030204" pitchFamily="18" charset="0"/>
                                             <a:cs typeface="Arial" panose="020B0604020202020204" pitchFamily="34" charset="0"/>
                                           </a:rPr>
-                                          <m:t>𝑠</m:t>
+                                          <m:t>𝒔</m:t>
                                         </m:r>
                                       </m:e>
                                       <m:sup>
                                         <m:r>
-                                          <a:rPr lang="es-ES" sz="1200" b="0" i="1" smtClean="0">
+                                          <a:rPr lang="es-ES" sz="1200" b="1" i="1" smtClean="0">
                                             <a:latin typeface="Cambria Math" panose="02040503050406030204" pitchFamily="18" charset="0"/>
                                             <a:cs typeface="Arial" panose="020B0604020202020204" pitchFamily="34" charset="0"/>
                                           </a:rPr>
-                                          <m:t>2</m:t>
+                                          <m:t>𝟐</m:t>
                                         </m:r>
                                       </m:sup>
                                     </m:sSup>
                                   </m:num>
                                   <m:den>
                                     <m:r>
-                                      <a:rPr lang="es-ES" sz="1200" b="0" i="1" smtClean="0">
+                                      <a:rPr lang="es-ES" sz="1200" b="1" i="1" smtClean="0">
                                         <a:latin typeface="Cambria Math" panose="02040503050406030204" pitchFamily="18" charset="0"/>
                                         <a:cs typeface="Arial" panose="020B0604020202020204" pitchFamily="34" charset="0"/>
                                       </a:rPr>
-                                      <m:t>𝑚</m:t>
+                                      <m:t>𝒎</m:t>
                                     </m:r>
                                   </m:den>
                                 </m:f>
@@ -7587,7 +7982,7 @@
                     </m:d>
                   </m:oMath>
                 </a14:m>
-                <a:endParaRPr lang="es-ES" sz="1200" b="0" dirty="0">
+                <a:endParaRPr lang="es-ES" sz="1200" b="1" dirty="0">
                   <a:latin typeface="Arial" panose="020B0604020202020204" pitchFamily="34" charset="0"/>
                   <a:cs typeface="Arial" panose="020B0604020202020204" pitchFamily="34" charset="0"/>
                 </a:endParaRPr>
@@ -7595,7 +7990,7 @@
               <a:p>
                 <a:pPr algn="just"/>
                 <a:r>
-                  <a:rPr lang="en-US" sz="1200" dirty="0">
+                  <a:rPr lang="en-US" sz="1200" b="1" dirty="0">
                     <a:latin typeface="Arial" panose="020B0604020202020204" pitchFamily="34" charset="0"/>
                     <a:cs typeface="Arial" panose="020B0604020202020204" pitchFamily="34" charset="0"/>
                   </a:rPr>
@@ -7605,7 +8000,7 @@
               <a:p>
                 <a:pPr algn="just"/>
                 <a:r>
-                  <a:rPr lang="en-US" sz="1200" dirty="0">
+                  <a:rPr lang="en-US" sz="1200" b="1" dirty="0">
                     <a:latin typeface="Arial" panose="020B0604020202020204" pitchFamily="34" charset="0"/>
                     <a:cs typeface="Arial" panose="020B0604020202020204" pitchFamily="34" charset="0"/>
                   </a:rPr>
@@ -7622,7 +8017,7 @@
             </p:txBody>
           </p:sp>
         </mc:Choice>
-        <mc:Fallback xmlns="">
+        <mc:Fallback>
           <p:sp>
             <p:nvSpPr>
               <p:cNvPr id="2" name="CuadroTexto 1">
@@ -7640,13 +8035,13 @@
             <p:spPr>
               <a:xfrm>
                 <a:off x="609441" y="4860334"/>
-                <a:ext cx="11198542" cy="1361911"/>
+                <a:ext cx="11198542" cy="1478738"/>
               </a:xfrm>
               <a:prstGeom prst="rect">
                 <a:avLst/>
               </a:prstGeom>
               <a:blipFill>
-                <a:blip r:embed="rId6"/>
+                <a:blip r:embed="rId5"/>
                 <a:stretch>
                   <a:fillRect/>
                 </a:stretch>
@@ -8119,10 +8514,10 @@
       </p:sp>
       <p:pic>
         <p:nvPicPr>
-          <p:cNvPr id="7" name="Imagen 6" descr="Gráfico, Gráfico de líneas&#10;&#10;El contenido generado por IA puede ser incorrecto.">
+          <p:cNvPr id="11" name="Imagen 10">
             <a:extLst>
               <a:ext uri="{FF2B5EF4-FFF2-40B4-BE49-F238E27FC236}">
-                <a16:creationId xmlns:a16="http://schemas.microsoft.com/office/drawing/2014/main" id="{79AB78F6-69A3-2828-4EA8-8747D257B466}"/>
+                <a16:creationId xmlns:a16="http://schemas.microsoft.com/office/drawing/2014/main" id="{B9237E19-5946-540E-DB76-1FCEC9593B92}"/>
               </a:ext>
             </a:extLst>
           </p:cNvPr>
@@ -8139,8 +8534,8 @@
         </p:blipFill>
         <p:spPr>
           <a:xfrm>
-            <a:off x="675640" y="1645068"/>
-            <a:ext cx="5338565" cy="2997223"/>
+            <a:off x="701037" y="1547610"/>
+            <a:ext cx="5339080" cy="2934933"/>
           </a:xfrm>
           <a:prstGeom prst="rect">
             <a:avLst/>
@@ -8149,10 +8544,10 @@
       </p:pic>
       <p:pic>
         <p:nvPicPr>
-          <p:cNvPr id="12" name="Imagen 11" descr="Gráfico, Gráfico de líneas&#10;&#10;El contenido generado por IA puede ser incorrecto.">
+          <p:cNvPr id="14" name="Imagen 13">
             <a:extLst>
               <a:ext uri="{FF2B5EF4-FFF2-40B4-BE49-F238E27FC236}">
-                <a16:creationId xmlns:a16="http://schemas.microsoft.com/office/drawing/2014/main" id="{AA9747B5-5460-ED3D-4EF2-C61D6D070C6F}"/>
+                <a16:creationId xmlns:a16="http://schemas.microsoft.com/office/drawing/2014/main" id="{A36F3AC6-2F4A-92F7-64ED-90083AC32784}"/>
               </a:ext>
             </a:extLst>
           </p:cNvPr>
@@ -8169,8 +8564,8 @@
         </p:blipFill>
         <p:spPr>
           <a:xfrm>
-            <a:off x="6414172" y="1688639"/>
-            <a:ext cx="5260958" cy="2953652"/>
+            <a:off x="6473023" y="1786382"/>
+            <a:ext cx="5242747" cy="2881978"/>
           </a:xfrm>
           <a:prstGeom prst="rect">
             <a:avLst/>
@@ -8198,6 +8593,616 @@
         <p:cNvPr id="1" name="">
           <a:extLst>
             <a:ext uri="{FF2B5EF4-FFF2-40B4-BE49-F238E27FC236}">
+              <a16:creationId xmlns:a16="http://schemas.microsoft.com/office/drawing/2014/main" id="{2FFD59C5-FBC3-0FF4-1B12-97CD17CE9902}"/>
+            </a:ext>
+          </a:extLst>
+        </p:cNvPr>
+        <p:cNvGrpSpPr/>
+        <p:nvPr/>
+      </p:nvGrpSpPr>
+      <p:grpSpPr>
+        <a:xfrm>
+          <a:off x="0" y="0"/>
+          <a:ext cx="0" cy="0"/>
+          <a:chOff x="0" y="0"/>
+          <a:chExt cx="0" cy="0"/>
+        </a:xfrm>
+      </p:grpSpPr>
+      <p:sp>
+        <p:nvSpPr>
+          <p:cNvPr id="16" name="object 16">
+            <a:extLst>
+              <a:ext uri="{FF2B5EF4-FFF2-40B4-BE49-F238E27FC236}">
+                <a16:creationId xmlns:a16="http://schemas.microsoft.com/office/drawing/2014/main" id="{664E4F01-A114-20B5-1CDE-10C8FF73920D}"/>
+              </a:ext>
+            </a:extLst>
+          </p:cNvPr>
+          <p:cNvSpPr txBox="1">
+            <a:spLocks noGrp="1"/>
+          </p:cNvSpPr>
+          <p:nvPr>
+            <p:ph type="title"/>
+          </p:nvPr>
+        </p:nvSpPr>
+        <p:spPr>
+          <a:xfrm>
+            <a:off x="685800" y="408883"/>
+            <a:ext cx="10994410" cy="1397819"/>
+          </a:xfrm>
+          <a:prstGeom prst="rect">
+            <a:avLst/>
+          </a:prstGeom>
+        </p:spPr>
+        <p:txBody>
+          <a:bodyPr vert="horz" wrap="square" lIns="0" tIns="12700" rIns="0" bIns="0" rtlCol="0">
+            <a:spAutoFit/>
+          </a:bodyPr>
+          <a:lstStyle/>
+          <a:p>
+            <a:pPr marL="12700">
+              <a:lnSpc>
+                <a:spcPct val="100000"/>
+              </a:lnSpc>
+              <a:spcBef>
+                <a:spcPts val="100"/>
+              </a:spcBef>
+            </a:pPr>
+            <a:r>
+              <a:rPr lang="en-US" sz="2500" dirty="0"/>
+              <a:t>Learning outcome #4 – Waveguide compact model</a:t>
+            </a:r>
+            <a:br>
+              <a:rPr lang="en-US" sz="2500" spc="-5" dirty="0">
+                <a:latin typeface="+mj-lt"/>
+                <a:cs typeface="Lucida Sans"/>
+              </a:rPr>
+            </a:br>
+            <a:r>
+              <a:rPr lang="en-US" b="0" dirty="0"/>
+              <a:t>- Find the compact models of the following waveguides: </a:t>
+            </a:r>
+            <a:br>
+              <a:rPr lang="en-US" b="0" dirty="0"/>
+            </a:br>
+            <a:r>
+              <a:rPr lang="en-US" dirty="0"/>
+              <a:t>Deep</a:t>
+            </a:r>
+            <a:r>
+              <a:rPr lang="en-US" b="0" dirty="0"/>
+              <a:t> waveguide, h=300nm, w=1.2um   - </a:t>
+            </a:r>
+            <a:r>
+              <a:rPr lang="en-US" dirty="0"/>
+              <a:t>Shallow</a:t>
+            </a:r>
+            <a:r>
+              <a:rPr lang="en-US" b="0" dirty="0"/>
+              <a:t> waveguide, core h=300nm, slab h=150 nm, w = 1.2um </a:t>
+            </a:r>
+            <a:br>
+              <a:rPr lang="en-US" b="0" dirty="0"/>
+            </a:br>
+            <a:endParaRPr lang="en-US" sz="2500" b="0" dirty="0">
+              <a:latin typeface="+mj-lt"/>
+              <a:cs typeface="Lucida Sans"/>
+            </a:endParaRPr>
+          </a:p>
+        </p:txBody>
+      </p:sp>
+      <p:pic>
+        <p:nvPicPr>
+          <p:cNvPr id="83" name="Gráfico 82">
+            <a:extLst>
+              <a:ext uri="{FF2B5EF4-FFF2-40B4-BE49-F238E27FC236}">
+                <a16:creationId xmlns:a16="http://schemas.microsoft.com/office/drawing/2014/main" id="{C216645F-71E2-FBBF-FB62-230B75925DF3}"/>
+              </a:ext>
+            </a:extLst>
+          </p:cNvPr>
+          <p:cNvPicPr>
+            <a:picLocks noChangeAspect="1"/>
+          </p:cNvPicPr>
+          <p:nvPr/>
+        </p:nvPicPr>
+        <p:blipFill>
+          <a:blip r:embed="rId3">
+            <a:extLst>
+              <a:ext uri="{96DAC541-7B7A-43D3-8B79-37D633B846F1}">
+                <asvg:svgBlip xmlns:asvg="http://schemas.microsoft.com/office/drawing/2016/SVG/main" r:embed="rId4"/>
+              </a:ext>
+            </a:extLst>
+          </a:blip>
+          <a:stretch>
+            <a:fillRect/>
+          </a:stretch>
+        </p:blipFill>
+        <p:spPr>
+          <a:xfrm>
+            <a:off x="5045006" y="6356057"/>
+            <a:ext cx="6409575" cy="363174"/>
+          </a:xfrm>
+          <a:prstGeom prst="rect">
+            <a:avLst/>
+          </a:prstGeom>
+        </p:spPr>
+      </p:pic>
+      <p:sp>
+        <p:nvSpPr>
+          <p:cNvPr id="84" name="Marcador de número de diapositiva 83">
+            <a:extLst>
+              <a:ext uri="{FF2B5EF4-FFF2-40B4-BE49-F238E27FC236}">
+                <a16:creationId xmlns:a16="http://schemas.microsoft.com/office/drawing/2014/main" id="{1FFB3D58-ED0E-39B4-6D91-E35FD3DE1511}"/>
+              </a:ext>
+            </a:extLst>
+          </p:cNvPr>
+          <p:cNvSpPr>
+            <a:spLocks noGrp="1"/>
+          </p:cNvSpPr>
+          <p:nvPr>
+            <p:ph type="sldNum" sz="quarter" idx="7"/>
+          </p:nvPr>
+        </p:nvSpPr>
+        <p:spPr/>
+        <p:txBody>
+          <a:bodyPr/>
+          <a:lstStyle/>
+          <a:p>
+            <a:fld id="{B6F15528-21DE-4FAA-801E-634DDDAF4B2B}" type="slidenum">
+              <a:rPr lang="es-ES" smtClean="0"/>
+              <a:t>7</a:t>
+            </a:fld>
+            <a:endParaRPr lang="es-ES"/>
+          </a:p>
+        </p:txBody>
+      </p:sp>
+      <p:sp>
+        <p:nvSpPr>
+          <p:cNvPr id="3" name="Marcador de pie de página 2">
+            <a:extLst>
+              <a:ext uri="{FF2B5EF4-FFF2-40B4-BE49-F238E27FC236}">
+                <a16:creationId xmlns:a16="http://schemas.microsoft.com/office/drawing/2014/main" id="{461F4473-B3C2-1E0B-9D4C-A7F4A0C402BD}"/>
+              </a:ext>
+            </a:extLst>
+          </p:cNvPr>
+          <p:cNvSpPr>
+            <a:spLocks noGrp="1"/>
+          </p:cNvSpPr>
+          <p:nvPr>
+            <p:ph type="ftr" sz="quarter" idx="5"/>
+          </p:nvPr>
+        </p:nvSpPr>
+        <p:spPr/>
+        <p:txBody>
+          <a:bodyPr/>
+          <a:lstStyle/>
+          <a:p>
+            <a:pPr marL="12700">
+              <a:spcBef>
+                <a:spcPts val="15"/>
+              </a:spcBef>
+            </a:pPr>
+            <a:r>
+              <a:rPr lang="es-ES" spc="-5"/>
+              <a:t>LAB 1.0 WAVEGUIDES</a:t>
+            </a:r>
+            <a:endParaRPr lang="es-ES" spc="-5" dirty="0"/>
+          </a:p>
+        </p:txBody>
+      </p:sp>
+      <p:sp>
+        <p:nvSpPr>
+          <p:cNvPr id="2" name="CuadroTexto 1">
+            <a:extLst>
+              <a:ext uri="{FF2B5EF4-FFF2-40B4-BE49-F238E27FC236}">
+                <a16:creationId xmlns:a16="http://schemas.microsoft.com/office/drawing/2014/main" id="{6587A331-6AEE-7432-20AB-A5026082703E}"/>
+              </a:ext>
+            </a:extLst>
+          </p:cNvPr>
+          <p:cNvSpPr txBox="1"/>
+          <p:nvPr/>
+        </p:nvSpPr>
+        <p:spPr>
+          <a:xfrm>
+            <a:off x="583734" y="1600200"/>
+            <a:ext cx="11198542" cy="3970318"/>
+          </a:xfrm>
+          <a:prstGeom prst="rect">
+            <a:avLst/>
+          </a:prstGeom>
+          <a:solidFill>
+            <a:schemeClr val="bg1">
+              <a:lumMod val="95000"/>
+            </a:schemeClr>
+          </a:solidFill>
+          <a:ln w="28575">
+            <a:solidFill>
+              <a:srgbClr val="E0700D"/>
+            </a:solidFill>
+          </a:ln>
+        </p:spPr>
+        <p:txBody>
+          <a:bodyPr wrap="square" rtlCol="0">
+            <a:spAutoFit/>
+          </a:bodyPr>
+          <a:lstStyle/>
+          <a:p>
+            <a:pPr algn="just"/>
+            <a:r>
+              <a:rPr lang="es-ES" sz="1200" dirty="0">
+                <a:latin typeface="Arial" panose="020B0604020202020204" pitchFamily="34" charset="0"/>
+                <a:cs typeface="Arial" panose="020B0604020202020204" pitchFamily="34" charset="0"/>
+              </a:rPr>
+              <a:t>En este ejercicio hemos obtenido los coeficientes del modelo compacto y, a partir de ellos, los valores de n, ng y D para los modos TE0 y TM0 en las guías </a:t>
+            </a:r>
+            <a:r>
+              <a:rPr lang="es-ES" sz="1200" dirty="0" err="1">
+                <a:latin typeface="Arial" panose="020B0604020202020204" pitchFamily="34" charset="0"/>
+                <a:cs typeface="Arial" panose="020B0604020202020204" pitchFamily="34" charset="0"/>
+              </a:rPr>
+              <a:t>deep</a:t>
+            </a:r>
+            <a:r>
+              <a:rPr lang="es-ES" sz="1200" dirty="0">
+                <a:latin typeface="Arial" panose="020B0604020202020204" pitchFamily="34" charset="0"/>
+                <a:cs typeface="Arial" panose="020B0604020202020204" pitchFamily="34" charset="0"/>
+              </a:rPr>
+              <a:t> y </a:t>
+            </a:r>
+            <a:r>
+              <a:rPr lang="es-ES" sz="1200" dirty="0" err="1">
+                <a:latin typeface="Arial" panose="020B0604020202020204" pitchFamily="34" charset="0"/>
+                <a:cs typeface="Arial" panose="020B0604020202020204" pitchFamily="34" charset="0"/>
+              </a:rPr>
+              <a:t>shallow</a:t>
+            </a:r>
+            <a:r>
+              <a:rPr lang="es-ES" sz="1200" dirty="0">
+                <a:latin typeface="Arial" panose="020B0604020202020204" pitchFamily="34" charset="0"/>
+                <a:cs typeface="Arial" panose="020B0604020202020204" pitchFamily="34" charset="0"/>
+              </a:rPr>
+              <a:t>. A partir de las gráficas y de los valores numéricos se ve que el ajuste representa muy bien los puntos simulados en todo el rango de 1.5 a 1.6 </a:t>
+            </a:r>
+            <a:r>
+              <a:rPr lang="es-ES" sz="1200" dirty="0" err="1">
+                <a:latin typeface="Arial" panose="020B0604020202020204" pitchFamily="34" charset="0"/>
+                <a:cs typeface="Arial" panose="020B0604020202020204" pitchFamily="34" charset="0"/>
+              </a:rPr>
+              <a:t>um</a:t>
+            </a:r>
+            <a:r>
+              <a:rPr lang="es-ES" sz="1200" dirty="0">
+                <a:latin typeface="Arial" panose="020B0604020202020204" pitchFamily="34" charset="0"/>
+                <a:cs typeface="Arial" panose="020B0604020202020204" pitchFamily="34" charset="0"/>
+              </a:rPr>
+              <a:t>, así que el modelo describe de forma adecuada la dependencia espectral de ambas guías alrededor de 1.55 </a:t>
+            </a:r>
+            <a:r>
+              <a:rPr lang="es-ES" sz="1200" dirty="0" err="1">
+                <a:latin typeface="Arial" panose="020B0604020202020204" pitchFamily="34" charset="0"/>
+                <a:cs typeface="Arial" panose="020B0604020202020204" pitchFamily="34" charset="0"/>
+              </a:rPr>
+              <a:t>um</a:t>
+            </a:r>
+            <a:r>
+              <a:rPr lang="es-ES" sz="1200" dirty="0">
+                <a:latin typeface="Arial" panose="020B0604020202020204" pitchFamily="34" charset="0"/>
+                <a:cs typeface="Arial" panose="020B0604020202020204" pitchFamily="34" charset="0"/>
+              </a:rPr>
+              <a:t>. En las cuatro curvas la variación de </a:t>
+            </a:r>
+            <a:r>
+              <a:rPr lang="es-ES" sz="1200" dirty="0" err="1">
+                <a:latin typeface="Arial" panose="020B0604020202020204" pitchFamily="34" charset="0"/>
+                <a:cs typeface="Arial" panose="020B0604020202020204" pitchFamily="34" charset="0"/>
+              </a:rPr>
+              <a:t>neff</a:t>
+            </a:r>
+            <a:r>
+              <a:rPr lang="es-ES" sz="1200" dirty="0">
+                <a:latin typeface="Arial" panose="020B0604020202020204" pitchFamily="34" charset="0"/>
+                <a:cs typeface="Arial" panose="020B0604020202020204" pitchFamily="34" charset="0"/>
+              </a:rPr>
+              <a:t> es suave y descendente con la longitud de onda, y eso queda reflejado también en que n2 es negativo en todos los casos. Por tanto, el comportamiento obtenido en el modelo compacto es coherente con lo que ya habíamos visto en el barrido en longitud de onda.</a:t>
+            </a:r>
+          </a:p>
+          <a:p>
+            <a:pPr algn="just"/>
+            <a:endParaRPr lang="es-ES" sz="1200" dirty="0">
+              <a:latin typeface="Arial" panose="020B0604020202020204" pitchFamily="34" charset="0"/>
+              <a:cs typeface="Arial" panose="020B0604020202020204" pitchFamily="34" charset="0"/>
+            </a:endParaRPr>
+          </a:p>
+          <a:p>
+            <a:pPr algn="just"/>
+            <a:r>
+              <a:rPr lang="es-ES" sz="1200" dirty="0">
+                <a:latin typeface="Arial" panose="020B0604020202020204" pitchFamily="34" charset="0"/>
+                <a:cs typeface="Arial" panose="020B0604020202020204" pitchFamily="34" charset="0"/>
+              </a:rPr>
+              <a:t>Comparando los modos, TE0 presenta siempre un valor de n mayor que TM0. En la guía </a:t>
+            </a:r>
+            <a:r>
+              <a:rPr lang="es-ES" sz="1200" dirty="0" err="1">
+                <a:latin typeface="Arial" panose="020B0604020202020204" pitchFamily="34" charset="0"/>
+                <a:cs typeface="Arial" panose="020B0604020202020204" pitchFamily="34" charset="0"/>
+              </a:rPr>
+              <a:t>deep</a:t>
+            </a:r>
+            <a:r>
+              <a:rPr lang="es-ES" sz="1200" dirty="0">
+                <a:latin typeface="Arial" panose="020B0604020202020204" pitchFamily="34" charset="0"/>
+                <a:cs typeface="Arial" panose="020B0604020202020204" pitchFamily="34" charset="0"/>
+              </a:rPr>
+              <a:t>, n vale 1.6049 para TE0 y 1.5272 para TM0, mientras que en la </a:t>
+            </a:r>
+            <a:r>
+              <a:rPr lang="es-ES" sz="1200" dirty="0" err="1">
+                <a:latin typeface="Arial" panose="020B0604020202020204" pitchFamily="34" charset="0"/>
+                <a:cs typeface="Arial" panose="020B0604020202020204" pitchFamily="34" charset="0"/>
+              </a:rPr>
+              <a:t>shallow</a:t>
+            </a:r>
+            <a:r>
+              <a:rPr lang="es-ES" sz="1200" dirty="0">
+                <a:latin typeface="Arial" panose="020B0604020202020204" pitchFamily="34" charset="0"/>
+                <a:cs typeface="Arial" panose="020B0604020202020204" pitchFamily="34" charset="0"/>
+              </a:rPr>
+              <a:t> vale 1.6241 para TE0 y 1.5419 para TM0. Esto indica que el modo TE0 está mejor guiado y más confinado que el TM0 en ambas geometrías. Además, al comparar </a:t>
+            </a:r>
+            <a:r>
+              <a:rPr lang="es-ES" sz="1200" dirty="0" err="1">
+                <a:latin typeface="Arial" panose="020B0604020202020204" pitchFamily="34" charset="0"/>
+                <a:cs typeface="Arial" panose="020B0604020202020204" pitchFamily="34" charset="0"/>
+              </a:rPr>
+              <a:t>deep</a:t>
+            </a:r>
+            <a:r>
+              <a:rPr lang="es-ES" sz="1200" dirty="0">
+                <a:latin typeface="Arial" panose="020B0604020202020204" pitchFamily="34" charset="0"/>
+                <a:cs typeface="Arial" panose="020B0604020202020204" pitchFamily="34" charset="0"/>
+              </a:rPr>
+              <a:t> y </a:t>
+            </a:r>
+            <a:r>
+              <a:rPr lang="es-ES" sz="1200" dirty="0" err="1">
+                <a:latin typeface="Arial" panose="020B0604020202020204" pitchFamily="34" charset="0"/>
+                <a:cs typeface="Arial" panose="020B0604020202020204" pitchFamily="34" charset="0"/>
+              </a:rPr>
+              <a:t>shallow</a:t>
+            </a:r>
+            <a:r>
+              <a:rPr lang="es-ES" sz="1200" dirty="0">
+                <a:latin typeface="Arial" panose="020B0604020202020204" pitchFamily="34" charset="0"/>
+                <a:cs typeface="Arial" panose="020B0604020202020204" pitchFamily="34" charset="0"/>
+              </a:rPr>
+              <a:t> se observa que la guía </a:t>
+            </a:r>
+            <a:r>
+              <a:rPr lang="es-ES" sz="1200" dirty="0" err="1">
+                <a:latin typeface="Arial" panose="020B0604020202020204" pitchFamily="34" charset="0"/>
+                <a:cs typeface="Arial" panose="020B0604020202020204" pitchFamily="34" charset="0"/>
+              </a:rPr>
+              <a:t>shallow</a:t>
+            </a:r>
+            <a:r>
+              <a:rPr lang="es-ES" sz="1200" dirty="0">
+                <a:latin typeface="Arial" panose="020B0604020202020204" pitchFamily="34" charset="0"/>
+                <a:cs typeface="Arial" panose="020B0604020202020204" pitchFamily="34" charset="0"/>
+              </a:rPr>
+              <a:t> da valores de n ligeramente superiores para los dos modos, lo que indica que la modificación geométrica entre ambas secciones influye de manera clara en la propagación y en el confinamiento del campo. La diferencia no es enorme, pero sí suficientemente clara como para apreciarse tanto en las gráficas como en los coeficientes obtenidos.</a:t>
+            </a:r>
+          </a:p>
+          <a:p>
+            <a:pPr algn="just"/>
+            <a:endParaRPr lang="es-ES" sz="1200" dirty="0">
+              <a:latin typeface="Arial" panose="020B0604020202020204" pitchFamily="34" charset="0"/>
+              <a:cs typeface="Arial" panose="020B0604020202020204" pitchFamily="34" charset="0"/>
+            </a:endParaRPr>
+          </a:p>
+          <a:p>
+            <a:pPr algn="just"/>
+            <a:r>
+              <a:rPr lang="es-ES" sz="1200" dirty="0">
+                <a:latin typeface="Arial" panose="020B0604020202020204" pitchFamily="34" charset="0"/>
+                <a:cs typeface="Arial" panose="020B0604020202020204" pitchFamily="34" charset="0"/>
+              </a:rPr>
+              <a:t>En cuanto al índice de grupo, en los cuatro casos resulta mayor que n. Esto es coherente con su definición, ya que ng no solo depende del valor de </a:t>
+            </a:r>
+            <a:r>
+              <a:rPr lang="es-ES" sz="1200" dirty="0" err="1">
+                <a:latin typeface="Arial" panose="020B0604020202020204" pitchFamily="34" charset="0"/>
+                <a:cs typeface="Arial" panose="020B0604020202020204" pitchFamily="34" charset="0"/>
+              </a:rPr>
+              <a:t>neff</a:t>
+            </a:r>
+            <a:r>
+              <a:rPr lang="es-ES" sz="1200" dirty="0">
+                <a:latin typeface="Arial" panose="020B0604020202020204" pitchFamily="34" charset="0"/>
+                <a:cs typeface="Arial" panose="020B0604020202020204" pitchFamily="34" charset="0"/>
+              </a:rPr>
+              <a:t> en la longitud de onda central, sino también de cómo cambia </a:t>
+            </a:r>
+            <a:r>
+              <a:rPr lang="es-ES" sz="1200" dirty="0" err="1">
+                <a:latin typeface="Arial" panose="020B0604020202020204" pitchFamily="34" charset="0"/>
+                <a:cs typeface="Arial" panose="020B0604020202020204" pitchFamily="34" charset="0"/>
+              </a:rPr>
+              <a:t>neff</a:t>
+            </a:r>
+            <a:r>
+              <a:rPr lang="es-ES" sz="1200" dirty="0">
+                <a:latin typeface="Arial" panose="020B0604020202020204" pitchFamily="34" charset="0"/>
+                <a:cs typeface="Arial" panose="020B0604020202020204" pitchFamily="34" charset="0"/>
+              </a:rPr>
+              <a:t> con lambda. También se aprecia que TE0 presenta valores de ng mayores que TM0, tanto en la guía </a:t>
+            </a:r>
+            <a:r>
+              <a:rPr lang="es-ES" sz="1200" dirty="0" err="1">
+                <a:latin typeface="Arial" panose="020B0604020202020204" pitchFamily="34" charset="0"/>
+                <a:cs typeface="Arial" panose="020B0604020202020204" pitchFamily="34" charset="0"/>
+              </a:rPr>
+              <a:t>deep</a:t>
+            </a:r>
+            <a:r>
+              <a:rPr lang="es-ES" sz="1200" dirty="0">
+                <a:latin typeface="Arial" panose="020B0604020202020204" pitchFamily="34" charset="0"/>
+                <a:cs typeface="Arial" panose="020B0604020202020204" pitchFamily="34" charset="0"/>
+              </a:rPr>
+              <a:t> como en la </a:t>
+            </a:r>
+            <a:r>
+              <a:rPr lang="es-ES" sz="1200" dirty="0" err="1">
+                <a:latin typeface="Arial" panose="020B0604020202020204" pitchFamily="34" charset="0"/>
+                <a:cs typeface="Arial" panose="020B0604020202020204" pitchFamily="34" charset="0"/>
+              </a:rPr>
+              <a:t>shallow</a:t>
+            </a:r>
+            <a:r>
+              <a:rPr lang="es-ES" sz="1200" dirty="0">
+                <a:latin typeface="Arial" panose="020B0604020202020204" pitchFamily="34" charset="0"/>
+                <a:cs typeface="Arial" panose="020B0604020202020204" pitchFamily="34" charset="0"/>
+              </a:rPr>
+              <a:t>. Respecto a la dispersión, D sale negativa en los cuatro casos, y además su valor absoluto es mayor en TM0 que en TE0. Eso indica que el modo TM0 es más dispersivo y, por tanto, más sensible a la dependencia con la longitud de onda. Comparando las dos geometrías, la </a:t>
+            </a:r>
+            <a:r>
+              <a:rPr lang="es-ES" sz="1200" dirty="0" err="1">
+                <a:latin typeface="Arial" panose="020B0604020202020204" pitchFamily="34" charset="0"/>
+                <a:cs typeface="Arial" panose="020B0604020202020204" pitchFamily="34" charset="0"/>
+              </a:rPr>
+              <a:t>shallow</a:t>
+            </a:r>
+            <a:r>
+              <a:rPr lang="es-ES" sz="1200" dirty="0">
+                <a:latin typeface="Arial" panose="020B0604020202020204" pitchFamily="34" charset="0"/>
+                <a:cs typeface="Arial" panose="020B0604020202020204" pitchFamily="34" charset="0"/>
+              </a:rPr>
+              <a:t> mantiene un </a:t>
+            </a:r>
+            <a:r>
+              <a:rPr lang="es-ES" sz="1200" dirty="0" err="1">
+                <a:latin typeface="Arial" panose="020B0604020202020204" pitchFamily="34" charset="0"/>
+                <a:cs typeface="Arial" panose="020B0604020202020204" pitchFamily="34" charset="0"/>
+              </a:rPr>
+              <a:t>neff</a:t>
+            </a:r>
+            <a:r>
+              <a:rPr lang="es-ES" sz="1200" dirty="0">
+                <a:latin typeface="Arial" panose="020B0604020202020204" pitchFamily="34" charset="0"/>
+                <a:cs typeface="Arial" panose="020B0604020202020204" pitchFamily="34" charset="0"/>
+              </a:rPr>
+              <a:t> algo mayor, pero no cambia la tendencia general: TE0 sigue siendo el modo dominante y TM0 sigue siendo el más afectado por la dispersión.</a:t>
+            </a:r>
+          </a:p>
+          <a:p>
+            <a:pPr algn="just"/>
+            <a:endParaRPr lang="es-ES" sz="1200" dirty="0">
+              <a:latin typeface="Arial" panose="020B0604020202020204" pitchFamily="34" charset="0"/>
+              <a:cs typeface="Arial" panose="020B0604020202020204" pitchFamily="34" charset="0"/>
+            </a:endParaRPr>
+          </a:p>
+          <a:p>
+            <a:pPr algn="just"/>
+            <a:r>
+              <a:rPr lang="es-ES" sz="1200" dirty="0">
+                <a:latin typeface="Arial" panose="020B0604020202020204" pitchFamily="34" charset="0"/>
+                <a:cs typeface="Arial" panose="020B0604020202020204" pitchFamily="34" charset="0"/>
+              </a:rPr>
+              <a:t>El ajuste de segundo orden reproduce correctamente la evolución espectral, la guía </a:t>
+            </a:r>
+            <a:r>
+              <a:rPr lang="es-ES" sz="1200" dirty="0" err="1">
+                <a:latin typeface="Arial" panose="020B0604020202020204" pitchFamily="34" charset="0"/>
+                <a:cs typeface="Arial" panose="020B0604020202020204" pitchFamily="34" charset="0"/>
+              </a:rPr>
+              <a:t>shallow</a:t>
+            </a:r>
+            <a:r>
+              <a:rPr lang="es-ES" sz="1200" dirty="0">
+                <a:latin typeface="Arial" panose="020B0604020202020204" pitchFamily="34" charset="0"/>
+                <a:cs typeface="Arial" panose="020B0604020202020204" pitchFamily="34" charset="0"/>
+              </a:rPr>
+              <a:t> presenta un </a:t>
+            </a:r>
+            <a:r>
+              <a:rPr lang="es-ES" sz="1200" dirty="0" err="1">
+                <a:latin typeface="Arial" panose="020B0604020202020204" pitchFamily="34" charset="0"/>
+                <a:cs typeface="Arial" panose="020B0604020202020204" pitchFamily="34" charset="0"/>
+              </a:rPr>
+              <a:t>neff</a:t>
+            </a:r>
+            <a:r>
+              <a:rPr lang="es-ES" sz="1200" dirty="0">
+                <a:latin typeface="Arial" panose="020B0604020202020204" pitchFamily="34" charset="0"/>
+                <a:cs typeface="Arial" panose="020B0604020202020204" pitchFamily="34" charset="0"/>
+              </a:rPr>
+              <a:t> ligeramente superior a la </a:t>
+            </a:r>
+            <a:r>
+              <a:rPr lang="es-ES" sz="1200" dirty="0" err="1">
+                <a:latin typeface="Arial" panose="020B0604020202020204" pitchFamily="34" charset="0"/>
+                <a:cs typeface="Arial" panose="020B0604020202020204" pitchFamily="34" charset="0"/>
+              </a:rPr>
+              <a:t>deep</a:t>
+            </a:r>
+            <a:r>
+              <a:rPr lang="es-ES" sz="1200" dirty="0">
+                <a:latin typeface="Arial" panose="020B0604020202020204" pitchFamily="34" charset="0"/>
+                <a:cs typeface="Arial" panose="020B0604020202020204" pitchFamily="34" charset="0"/>
+              </a:rPr>
+              <a:t>, el modo TE0 es el mejor confinado en los dos casos y el modo TM0 es el que presenta una dispersión más acusada. Por tanto, el modelo compacto no solo resume bien los resultados de simulación, sino que además permite extraer de forma clara las diferencias entre </a:t>
+            </a:r>
+            <a:r>
+              <a:rPr lang="es-ES" sz="1200" dirty="0" err="1">
+                <a:latin typeface="Arial" panose="020B0604020202020204" pitchFamily="34" charset="0"/>
+                <a:cs typeface="Arial" panose="020B0604020202020204" pitchFamily="34" charset="0"/>
+              </a:rPr>
+              <a:t>deep</a:t>
+            </a:r>
+            <a:r>
+              <a:rPr lang="es-ES" sz="1200" dirty="0">
+                <a:latin typeface="Arial" panose="020B0604020202020204" pitchFamily="34" charset="0"/>
+                <a:cs typeface="Arial" panose="020B0604020202020204" pitchFamily="34" charset="0"/>
+              </a:rPr>
+              <a:t> y </a:t>
+            </a:r>
+            <a:r>
+              <a:rPr lang="es-ES" sz="1200" dirty="0" err="1">
+                <a:latin typeface="Arial" panose="020B0604020202020204" pitchFamily="34" charset="0"/>
+                <a:cs typeface="Arial" panose="020B0604020202020204" pitchFamily="34" charset="0"/>
+              </a:rPr>
+              <a:t>shallow</a:t>
+            </a:r>
+            <a:r>
+              <a:rPr lang="es-ES" sz="1200" dirty="0">
+                <a:latin typeface="Arial" panose="020B0604020202020204" pitchFamily="34" charset="0"/>
+                <a:cs typeface="Arial" panose="020B0604020202020204" pitchFamily="34" charset="0"/>
+              </a:rPr>
+              <a:t> y entre los modos TE0 y TM0.</a:t>
+            </a:r>
+          </a:p>
+        </p:txBody>
+      </p:sp>
+    </p:spTree>
+    <p:extLst>
+      <p:ext uri="{BB962C8B-B14F-4D97-AF65-F5344CB8AC3E}">
+        <p14:creationId xmlns:p14="http://schemas.microsoft.com/office/powerpoint/2010/main" val="1592548045"/>
+      </p:ext>
+    </p:extLst>
+  </p:cSld>
+  <p:clrMapOvr>
+    <a:masterClrMapping/>
+  </p:clrMapOvr>
+</p:sld>
+</file>
+
+<file path=ppt/slides/slide8.xml><?xml version="1.0" encoding="utf-8"?>
+<p:sld xmlns:a="http://schemas.openxmlformats.org/drawingml/2006/main" xmlns:r="http://schemas.openxmlformats.org/officeDocument/2006/relationships" xmlns:p="http://schemas.openxmlformats.org/presentationml/2006/main">
+  <p:cSld>
+    <p:spTree>
+      <p:nvGrpSpPr>
+        <p:cNvPr id="1" name="">
+          <a:extLst>
+            <a:ext uri="{FF2B5EF4-FFF2-40B4-BE49-F238E27FC236}">
               <a16:creationId xmlns:a16="http://schemas.microsoft.com/office/drawing/2014/main" id="{25434E70-43B1-3881-1771-20FB4358471D}"/>
             </a:ext>
           </a:extLst>
@@ -8340,7 +9345,7 @@
           <a:p>
             <a:fld id="{B6F15528-21DE-4FAA-801E-634DDDAF4B2B}" type="slidenum">
               <a:rPr lang="es-ES" smtClean="0"/>
-              <a:t>7</a:t>
+              <a:t>8</a:t>
             </a:fld>
             <a:endParaRPr lang="es-ES"/>
           </a:p>
@@ -8395,7 +9400,7 @@
         <p:spPr>
           <a:xfrm>
             <a:off x="609441" y="4860334"/>
-            <a:ext cx="11199971" cy="1200329"/>
+            <a:ext cx="11199971" cy="1384995"/>
           </a:xfrm>
           <a:prstGeom prst="rect">
             <a:avLst/>
@@ -8419,22 +9424,68 @@
           <a:p>
             <a:pPr algn="just"/>
             <a:r>
-              <a:rPr lang="en-US" sz="1200" dirty="0">
-                <a:latin typeface="Arial" panose="020B0604020202020204" pitchFamily="34" charset="0"/>
-                <a:cs typeface="Arial" panose="020B0604020202020204" pitchFamily="34" charset="0"/>
-              </a:rPr>
-              <a:t>Comment results, which is the safe radius?, consider safe means less than 0.1 dB/90º.</a:t>
-            </a:r>
-          </a:p>
-          <a:p>
-            <a:pPr algn="just"/>
-            <a:endParaRPr lang="en-US" sz="1200" u="sng" dirty="0">
+              <a:rPr lang="en-US" sz="1200" b="1" dirty="0">
+                <a:latin typeface="Arial" panose="020B0604020202020204" pitchFamily="34" charset="0"/>
+                <a:cs typeface="Arial" panose="020B0604020202020204" pitchFamily="34" charset="0"/>
+              </a:rPr>
+              <a:t>Comment results, which is the safe radius?, consider safe means less than 0.1 dB/90º</a:t>
+            </a:r>
+            <a:endParaRPr lang="es-ES" sz="1200" b="1" dirty="0">
               <a:latin typeface="Arial" panose="020B0604020202020204" pitchFamily="34" charset="0"/>
               <a:cs typeface="Arial" panose="020B0604020202020204" pitchFamily="34" charset="0"/>
             </a:endParaRPr>
           </a:p>
           <a:p>
             <a:pPr algn="just"/>
+            <a:r>
+              <a:rPr lang="es-ES" sz="1200" dirty="0">
+                <a:latin typeface="Arial" panose="020B0604020202020204" pitchFamily="34" charset="0"/>
+                <a:cs typeface="Arial" panose="020B0604020202020204" pitchFamily="34" charset="0"/>
+              </a:rPr>
+              <a:t>La pérdida total disminuye al aumentar el radio de curvatura, porque una curva más suave introduce menos desajuste entre la guía recta y la curvada. Como hemos visto en teoría, en una guía curvada el modo se desplaza hacia la parte exterior de la curva y eso puede aumentar las pérdidas por </a:t>
+            </a:r>
+            <a:r>
+              <a:rPr lang="es-ES" sz="1200" dirty="0" err="1">
+                <a:latin typeface="Arial" panose="020B0604020202020204" pitchFamily="34" charset="0"/>
+                <a:cs typeface="Arial" panose="020B0604020202020204" pitchFamily="34" charset="0"/>
+              </a:rPr>
+              <a:t>mismatch</a:t>
+            </a:r>
+            <a:r>
+              <a:rPr lang="es-ES" sz="1200" dirty="0">
+                <a:latin typeface="Arial" panose="020B0604020202020204" pitchFamily="34" charset="0"/>
+                <a:cs typeface="Arial" panose="020B0604020202020204" pitchFamily="34" charset="0"/>
+              </a:rPr>
+              <a:t> en la transición recta-curva. En nuestros resultados R = 25 µm no es seguro porque supera 0.1 dB/90º, mientras que desde R = 50 µm la pérdida total ya queda por debajo de ese valor. Por tanto, el </a:t>
+            </a:r>
+            <a:r>
+              <a:rPr lang="es-ES" sz="1200" dirty="0" err="1">
+                <a:latin typeface="Arial" panose="020B0604020202020204" pitchFamily="34" charset="0"/>
+                <a:cs typeface="Arial" panose="020B0604020202020204" pitchFamily="34" charset="0"/>
+              </a:rPr>
+              <a:t>safe</a:t>
+            </a:r>
+            <a:r>
+              <a:rPr lang="es-ES" sz="1200" dirty="0">
+                <a:latin typeface="Arial" panose="020B0604020202020204" pitchFamily="34" charset="0"/>
+                <a:cs typeface="Arial" panose="020B0604020202020204" pitchFamily="34" charset="0"/>
+              </a:rPr>
+              <a:t> </a:t>
+            </a:r>
+            <a:r>
+              <a:rPr lang="es-ES" sz="1200" dirty="0" err="1">
+                <a:latin typeface="Arial" panose="020B0604020202020204" pitchFamily="34" charset="0"/>
+                <a:cs typeface="Arial" panose="020B0604020202020204" pitchFamily="34" charset="0"/>
+              </a:rPr>
+              <a:t>radius</a:t>
+            </a:r>
+            <a:r>
+              <a:rPr lang="es-ES" sz="1200" dirty="0">
+                <a:latin typeface="Arial" panose="020B0604020202020204" pitchFamily="34" charset="0"/>
+                <a:cs typeface="Arial" panose="020B0604020202020204" pitchFamily="34" charset="0"/>
+              </a:rPr>
+              <a:t> es 50 µm. Además, neff_TE0 varía más para radios pequeños y después se estabiliza, así que las curvas cerradas afectan más al modo que las curvas grandes.</a:t>
+            </a:r>
             <a:endParaRPr lang="en-US" sz="1200" dirty="0">
               <a:latin typeface="Arial" panose="020B0604020202020204" pitchFamily="34" charset="0"/>
               <a:cs typeface="Arial" panose="020B0604020202020204" pitchFamily="34" charset="0"/>
@@ -8442,21 +9493,7 @@
           </a:p>
           <a:p>
             <a:pPr algn="just"/>
-            <a:endParaRPr lang="en-US" sz="1200" dirty="0">
-              <a:latin typeface="Arial" panose="020B0604020202020204" pitchFamily="34" charset="0"/>
-              <a:cs typeface="Arial" panose="020B0604020202020204" pitchFamily="34" charset="0"/>
-            </a:endParaRPr>
-          </a:p>
-          <a:p>
-            <a:pPr algn="just"/>
-            <a:endParaRPr lang="en-US" sz="1200" dirty="0">
-              <a:latin typeface="Arial" panose="020B0604020202020204" pitchFamily="34" charset="0"/>
-              <a:cs typeface="Arial" panose="020B0604020202020204" pitchFamily="34" charset="0"/>
-            </a:endParaRPr>
-          </a:p>
-          <a:p>
-            <a:pPr algn="just"/>
-            <a:endParaRPr lang="en-US" sz="1200" dirty="0">
+            <a:endParaRPr lang="en-US" sz="1200" u="sng" dirty="0">
               <a:latin typeface="Arial" panose="020B0604020202020204" pitchFamily="34" charset="0"/>
               <a:cs typeface="Arial" panose="020B0604020202020204" pitchFamily="34" charset="0"/>
             </a:endParaRPr>
@@ -8566,6 +9603,66 @@
           </a:p>
         </p:txBody>
       </p:sp>
+      <p:pic>
+        <p:nvPicPr>
+          <p:cNvPr id="5" name="Imagen 4">
+            <a:extLst>
+              <a:ext uri="{FF2B5EF4-FFF2-40B4-BE49-F238E27FC236}">
+                <a16:creationId xmlns:a16="http://schemas.microsoft.com/office/drawing/2014/main" id="{6EF9C501-C582-C2B4-0E61-FC1F40E92975}"/>
+              </a:ext>
+            </a:extLst>
+          </p:cNvPr>
+          <p:cNvPicPr>
+            <a:picLocks noChangeAspect="1"/>
+          </p:cNvPicPr>
+          <p:nvPr/>
+        </p:nvPicPr>
+        <p:blipFill>
+          <a:blip r:embed="rId5"/>
+          <a:stretch>
+            <a:fillRect/>
+          </a:stretch>
+        </p:blipFill>
+        <p:spPr>
+          <a:xfrm>
+            <a:off x="634048" y="1541893"/>
+            <a:ext cx="5548957" cy="3050303"/>
+          </a:xfrm>
+          <a:prstGeom prst="rect">
+            <a:avLst/>
+          </a:prstGeom>
+        </p:spPr>
+      </p:pic>
+      <p:pic>
+        <p:nvPicPr>
+          <p:cNvPr id="9" name="Imagen 8">
+            <a:extLst>
+              <a:ext uri="{FF2B5EF4-FFF2-40B4-BE49-F238E27FC236}">
+                <a16:creationId xmlns:a16="http://schemas.microsoft.com/office/drawing/2014/main" id="{E7798CAC-B41A-312E-8757-C99E11F51799}"/>
+              </a:ext>
+            </a:extLst>
+          </p:cNvPr>
+          <p:cNvPicPr>
+            <a:picLocks noChangeAspect="1"/>
+          </p:cNvPicPr>
+          <p:nvPr/>
+        </p:nvPicPr>
+        <p:blipFill>
+          <a:blip r:embed="rId6"/>
+          <a:stretch>
+            <a:fillRect/>
+          </a:stretch>
+        </p:blipFill>
+        <p:spPr>
+          <a:xfrm>
+            <a:off x="6183005" y="1554709"/>
+            <a:ext cx="5618164" cy="3024670"/>
+          </a:xfrm>
+          <a:prstGeom prst="rect">
+            <a:avLst/>
+          </a:prstGeom>
+        </p:spPr>
+      </p:pic>
     </p:spTree>
     <p:extLst>
       <p:ext uri="{BB962C8B-B14F-4D97-AF65-F5344CB8AC3E}">
@@ -8579,12 +9676,18 @@
 </p:sld>
 </file>
 
-<file path=ppt/slides/slide8.xml><?xml version="1.0" encoding="utf-8"?>
+<file path=ppt/slides/slide9.xml><?xml version="1.0" encoding="utf-8"?>
 <p:sld xmlns:a="http://schemas.openxmlformats.org/drawingml/2006/main" xmlns:r="http://schemas.openxmlformats.org/officeDocument/2006/relationships" xmlns:p="http://schemas.openxmlformats.org/presentationml/2006/main">
   <p:cSld>
     <p:spTree>
       <p:nvGrpSpPr>
-        <p:cNvPr id="1" name=""/>
+        <p:cNvPr id="1" name="">
+          <a:extLst>
+            <a:ext uri="{FF2B5EF4-FFF2-40B4-BE49-F238E27FC236}">
+              <a16:creationId xmlns:a16="http://schemas.microsoft.com/office/drawing/2014/main" id="{0D936354-732D-45BB-61B1-BD7B973D142A}"/>
+            </a:ext>
+          </a:extLst>
+        </p:cNvPr>
         <p:cNvGrpSpPr/>
         <p:nvPr/>
       </p:nvGrpSpPr>
@@ -8598,36 +9701,13 @@
       </p:grpSpPr>
       <p:sp>
         <p:nvSpPr>
-          <p:cNvPr id="3" name="object 3"/>
-          <p:cNvSpPr/>
-          <p:nvPr/>
-        </p:nvSpPr>
-        <p:spPr>
-          <a:xfrm>
-            <a:off x="3945635" y="2636520"/>
-            <a:ext cx="8246363" cy="1584959"/>
-          </a:xfrm>
-          <a:prstGeom prst="rect">
-            <a:avLst/>
-          </a:prstGeom>
-          <a:blipFill>
-            <a:blip r:embed="rId2" cstate="print"/>
-            <a:stretch>
-              <a:fillRect/>
-            </a:stretch>
-          </a:blipFill>
-        </p:spPr>
-        <p:txBody>
-          <a:bodyPr wrap="square" lIns="0" tIns="0" rIns="0" bIns="0" rtlCol="0"/>
-          <a:lstStyle/>
-          <a:p>
-            <a:endParaRPr/>
-          </a:p>
-        </p:txBody>
-      </p:sp>
-      <p:sp>
-        <p:nvSpPr>
-          <p:cNvPr id="4" name="object 4"/>
+          <p:cNvPr id="16" name="object 16">
+            <a:extLst>
+              <a:ext uri="{FF2B5EF4-FFF2-40B4-BE49-F238E27FC236}">
+                <a16:creationId xmlns:a16="http://schemas.microsoft.com/office/drawing/2014/main" id="{BABE07EF-84A8-DC96-A090-AA53ADB479D9}"/>
+              </a:ext>
+            </a:extLst>
+          </p:cNvPr>
           <p:cNvSpPr txBox="1">
             <a:spLocks noGrp="1"/>
           </p:cNvSpPr>
@@ -8637,15 +9717,15 @@
         </p:nvSpPr>
         <p:spPr>
           <a:xfrm>
-            <a:off x="4513326" y="3165729"/>
-            <a:ext cx="2233295" cy="513715"/>
+            <a:off x="685800" y="408883"/>
+            <a:ext cx="10994410" cy="782265"/>
           </a:xfrm>
           <a:prstGeom prst="rect">
             <a:avLst/>
           </a:prstGeom>
         </p:spPr>
         <p:txBody>
-          <a:bodyPr vert="horz" wrap="square" lIns="0" tIns="13335" rIns="0" bIns="0" rtlCol="0">
+          <a:bodyPr vert="horz" wrap="square" lIns="0" tIns="12700" rIns="0" bIns="0" rtlCol="0">
             <a:spAutoFit/>
           </a:bodyPr>
           <a:lstStyle/>
@@ -8655,52 +9735,65 @@
                 <a:spcPct val="100000"/>
               </a:lnSpc>
               <a:spcBef>
-                <a:spcPts val="105"/>
+                <a:spcPts val="100"/>
               </a:spcBef>
             </a:pPr>
             <a:r>
-              <a:rPr sz="3200" b="1" spc="-5" dirty="0">
-                <a:solidFill>
-                  <a:srgbClr val="FFFFFF"/>
-                </a:solidFill>
-                <a:latin typeface="Lucida Sans"/>
-                <a:cs typeface="Lucida Sans"/>
-              </a:rPr>
-              <a:t>Thank</a:t>
-            </a:r>
-            <a:r>
-              <a:rPr sz="3200" b="1" spc="-55" dirty="0">
-                <a:solidFill>
-                  <a:srgbClr val="FFFFFF"/>
-                </a:solidFill>
-                <a:latin typeface="Lucida Sans"/>
-                <a:cs typeface="Lucida Sans"/>
-              </a:rPr>
-              <a:t> </a:t>
-            </a:r>
-            <a:r>
-              <a:rPr sz="3200" b="1" dirty="0">
-                <a:solidFill>
-                  <a:srgbClr val="FFFFFF"/>
-                </a:solidFill>
-                <a:latin typeface="Lucida Sans"/>
-                <a:cs typeface="Lucida Sans"/>
-              </a:rPr>
-              <a:t>you</a:t>
-            </a:r>
-            <a:endParaRPr sz="3200">
-              <a:latin typeface="Lucida Sans"/>
+              <a:rPr lang="en-US" sz="2500" dirty="0"/>
+              <a:t>EXTRA?</a:t>
+            </a:r>
+            <a:br>
+              <a:rPr lang="en-US" sz="2500" dirty="0"/>
+            </a:br>
+            <a:endParaRPr lang="en-US" sz="2500" b="0" dirty="0">
+              <a:latin typeface="+mj-lt"/>
               <a:cs typeface="Lucida Sans"/>
             </a:endParaRPr>
           </a:p>
         </p:txBody>
       </p:sp>
-      <p:sp>
-        <p:nvSpPr>
-          <p:cNvPr id="5" name="Marcador de número de diapositiva 4">
+      <p:pic>
+        <p:nvPicPr>
+          <p:cNvPr id="83" name="Gráfico 82">
             <a:extLst>
               <a:ext uri="{FF2B5EF4-FFF2-40B4-BE49-F238E27FC236}">
-                <a16:creationId xmlns:a16="http://schemas.microsoft.com/office/drawing/2014/main" id="{B052DA19-AD24-7D24-2AE9-51F8F5A7F5E0}"/>
+                <a16:creationId xmlns:a16="http://schemas.microsoft.com/office/drawing/2014/main" id="{2DD9C130-1A6A-EDAF-D0A8-AE339F420334}"/>
+              </a:ext>
+            </a:extLst>
+          </p:cNvPr>
+          <p:cNvPicPr>
+            <a:picLocks noChangeAspect="1"/>
+          </p:cNvPicPr>
+          <p:nvPr/>
+        </p:nvPicPr>
+        <p:blipFill>
+          <a:blip r:embed="rId3">
+            <a:extLst>
+              <a:ext uri="{96DAC541-7B7A-43D3-8B79-37D633B846F1}">
+                <asvg:svgBlip xmlns:asvg="http://schemas.microsoft.com/office/drawing/2016/SVG/main" r:embed="rId4"/>
+              </a:ext>
+            </a:extLst>
+          </a:blip>
+          <a:stretch>
+            <a:fillRect/>
+          </a:stretch>
+        </p:blipFill>
+        <p:spPr>
+          <a:xfrm>
+            <a:off x="5045006" y="6356057"/>
+            <a:ext cx="6409575" cy="363174"/>
+          </a:xfrm>
+          <a:prstGeom prst="rect">
+            <a:avLst/>
+          </a:prstGeom>
+        </p:spPr>
+      </p:pic>
+      <p:sp>
+        <p:nvSpPr>
+          <p:cNvPr id="84" name="Marcador de número de diapositiva 83">
+            <a:extLst>
+              <a:ext uri="{FF2B5EF4-FFF2-40B4-BE49-F238E27FC236}">
+                <a16:creationId xmlns:a16="http://schemas.microsoft.com/office/drawing/2014/main" id="{C956E172-4CC2-AEA9-14C4-B6455016DA85}"/>
               </a:ext>
             </a:extLst>
           </p:cNvPr>
@@ -8718,13 +9811,177 @@
           <a:p>
             <a:fld id="{B6F15528-21DE-4FAA-801E-634DDDAF4B2B}" type="slidenum">
               <a:rPr lang="es-ES" smtClean="0"/>
-              <a:t>8</a:t>
+              <a:t>9</a:t>
             </a:fld>
             <a:endParaRPr lang="es-ES"/>
           </a:p>
         </p:txBody>
       </p:sp>
+      <p:sp>
+        <p:nvSpPr>
+          <p:cNvPr id="3" name="Marcador de pie de página 2">
+            <a:extLst>
+              <a:ext uri="{FF2B5EF4-FFF2-40B4-BE49-F238E27FC236}">
+                <a16:creationId xmlns:a16="http://schemas.microsoft.com/office/drawing/2014/main" id="{8989475A-7106-C333-CAF3-24C9572E4BC1}"/>
+              </a:ext>
+            </a:extLst>
+          </p:cNvPr>
+          <p:cNvSpPr>
+            <a:spLocks noGrp="1"/>
+          </p:cNvSpPr>
+          <p:nvPr>
+            <p:ph type="ftr" sz="quarter" idx="5"/>
+          </p:nvPr>
+        </p:nvSpPr>
+        <p:spPr/>
+        <p:txBody>
+          <a:bodyPr/>
+          <a:lstStyle/>
+          <a:p>
+            <a:pPr marL="12700">
+              <a:spcBef>
+                <a:spcPts val="15"/>
+              </a:spcBef>
+            </a:pPr>
+            <a:r>
+              <a:rPr lang="es-ES" spc="-5"/>
+              <a:t>LAB 1.0 WAVEGUIDES</a:t>
+            </a:r>
+            <a:endParaRPr lang="es-ES" spc="-5" dirty="0"/>
+          </a:p>
+        </p:txBody>
+      </p:sp>
+      <p:sp>
+        <p:nvSpPr>
+          <p:cNvPr id="2" name="CuadroTexto 1">
+            <a:extLst>
+              <a:ext uri="{FF2B5EF4-FFF2-40B4-BE49-F238E27FC236}">
+                <a16:creationId xmlns:a16="http://schemas.microsoft.com/office/drawing/2014/main" id="{23D724CB-E3A1-0B12-37FE-A325A1D3C438}"/>
+              </a:ext>
+            </a:extLst>
+          </p:cNvPr>
+          <p:cNvSpPr txBox="1"/>
+          <p:nvPr/>
+        </p:nvSpPr>
+        <p:spPr>
+          <a:xfrm>
+            <a:off x="609441" y="4860334"/>
+            <a:ext cx="11199971" cy="1015663"/>
+          </a:xfrm>
+          <a:prstGeom prst="rect">
+            <a:avLst/>
+          </a:prstGeom>
+          <a:solidFill>
+            <a:schemeClr val="bg1">
+              <a:lumMod val="95000"/>
+            </a:schemeClr>
+          </a:solidFill>
+          <a:ln w="28575">
+            <a:solidFill>
+              <a:srgbClr val="E0700D"/>
+            </a:solidFill>
+          </a:ln>
+        </p:spPr>
+        <p:txBody>
+          <a:bodyPr wrap="square" rtlCol="0">
+            <a:spAutoFit/>
+          </a:bodyPr>
+          <a:lstStyle/>
+          <a:p>
+            <a:pPr algn="just"/>
+            <a:endParaRPr lang="en-US" sz="1200" u="sng" dirty="0">
+              <a:latin typeface="Arial" panose="020B0604020202020204" pitchFamily="34" charset="0"/>
+              <a:cs typeface="Arial" panose="020B0604020202020204" pitchFamily="34" charset="0"/>
+            </a:endParaRPr>
+          </a:p>
+          <a:p>
+            <a:pPr algn="just"/>
+            <a:endParaRPr lang="en-US" sz="1200" dirty="0">
+              <a:latin typeface="Arial" panose="020B0604020202020204" pitchFamily="34" charset="0"/>
+              <a:cs typeface="Arial" panose="020B0604020202020204" pitchFamily="34" charset="0"/>
+            </a:endParaRPr>
+          </a:p>
+          <a:p>
+            <a:pPr algn="just"/>
+            <a:endParaRPr lang="en-US" sz="1200" dirty="0">
+              <a:latin typeface="Arial" panose="020B0604020202020204" pitchFamily="34" charset="0"/>
+              <a:cs typeface="Arial" panose="020B0604020202020204" pitchFamily="34" charset="0"/>
+            </a:endParaRPr>
+          </a:p>
+          <a:p>
+            <a:pPr algn="just"/>
+            <a:endParaRPr lang="en-US" sz="1200" dirty="0">
+              <a:latin typeface="Arial" panose="020B0604020202020204" pitchFamily="34" charset="0"/>
+              <a:cs typeface="Arial" panose="020B0604020202020204" pitchFamily="34" charset="0"/>
+            </a:endParaRPr>
+          </a:p>
+          <a:p>
+            <a:pPr algn="just"/>
+            <a:endParaRPr lang="en-US" sz="1200" dirty="0">
+              <a:latin typeface="Arial" panose="020B0604020202020204" pitchFamily="34" charset="0"/>
+              <a:cs typeface="Arial" panose="020B0604020202020204" pitchFamily="34" charset="0"/>
+            </a:endParaRPr>
+          </a:p>
+        </p:txBody>
+      </p:sp>
+      <p:sp>
+        <p:nvSpPr>
+          <p:cNvPr id="7" name="Rectángulo 6">
+            <a:extLst>
+              <a:ext uri="{FF2B5EF4-FFF2-40B4-BE49-F238E27FC236}">
+                <a16:creationId xmlns:a16="http://schemas.microsoft.com/office/drawing/2014/main" id="{C6CB24D1-A781-6B22-CD3E-63AC1E4D166F}"/>
+              </a:ext>
+            </a:extLst>
+          </p:cNvPr>
+          <p:cNvSpPr/>
+          <p:nvPr/>
+        </p:nvSpPr>
+        <p:spPr>
+          <a:xfrm>
+            <a:off x="609441" y="1418373"/>
+            <a:ext cx="11199971" cy="3306028"/>
+          </a:xfrm>
+          <a:prstGeom prst="rect">
+            <a:avLst/>
+          </a:prstGeom>
+          <a:noFill/>
+          <a:ln w="28575">
+            <a:solidFill>
+              <a:srgbClr val="E0700D"/>
+            </a:solidFill>
+          </a:ln>
+        </p:spPr>
+        <p:style>
+          <a:lnRef idx="2">
+            <a:schemeClr val="accent1">
+              <a:shade val="15000"/>
+            </a:schemeClr>
+          </a:lnRef>
+          <a:fillRef idx="1">
+            <a:schemeClr val="accent1"/>
+          </a:fillRef>
+          <a:effectRef idx="0">
+            <a:schemeClr val="accent1"/>
+          </a:effectRef>
+          <a:fontRef idx="minor">
+            <a:schemeClr val="lt1"/>
+          </a:fontRef>
+        </p:style>
+        <p:txBody>
+          <a:bodyPr rtlCol="0" anchor="ctr"/>
+          <a:lstStyle/>
+          <a:p>
+            <a:pPr algn="ctr"/>
+            <a:endParaRPr lang="en-US"/>
+          </a:p>
+        </p:txBody>
+      </p:sp>
     </p:spTree>
+    <p:extLst>
+      <p:ext uri="{BB962C8B-B14F-4D97-AF65-F5344CB8AC3E}">
+        <p14:creationId xmlns:p14="http://schemas.microsoft.com/office/powerpoint/2010/main" val="223640977"/>
+      </p:ext>
+    </p:extLst>
   </p:cSld>
   <p:clrMapOvr>
     <a:masterClrMapping/>

</xml_diff>